<commit_message>
Documentar indicadores y corregir informes descargables
</commit_message>
<xml_diff>
--- a/docs/presentacion_defensa_tfg_riego_jurado.pptx
+++ b/docs/presentacion_defensa_tfg_riego_jurado.pptx
@@ -6654,127 +6654,127 @@
 </file>
 
 <file path=ppt/slides/slide12.xml><?xml version="1.0" encoding="utf-8"?>
-<p:sld xmlns:p="http://schemas.openxmlformats.org/presentationml/2006/main">
-  <p:cSld>
-    <p:spTree>
-      <p:nvGrpSpPr>
-        <p:cNvPr id="1" name=""/>
-        <p:cNvGrpSpPr/>
-        <p:nvPr/>
-      </p:nvGrpSpPr>
-      <p:grpSpPr>
-        <a:xfrm xmlns:a="http://schemas.openxmlformats.org/drawingml/2006/main"/>
-      </p:grpSpPr>
-      <p:sp>
-        <p:nvSpPr>
-          <p:cNvPr id="1" name="">
-            <a:extLst xmlns:a="http://schemas.openxmlformats.org/drawingml/2006/main">
-              <a:ext uri="{FF2B5EF4-FFF2-40B4-BE49-F238E27FC236}">
-                <a16:creationId xmlns:a16="http://schemas.microsoft.com/office/drawing/2014/main" id="{72FAC77F-4EE2-4380-B9AF-C3F39077ECED}"/>
-              </a:ext>
-            </a:extLst>
-          </p:cNvPr>
-          <p:cNvSpPr>
-            <a:spLocks xmlns:a="http://schemas.openxmlformats.org/drawingml/2006/main" noGrp="1"/>
-          </p:cNvSpPr>
-          <p:nvPr/>
-        </p:nvSpPr>
-        <p:spPr>
-          <a:xfrm xmlns:a="http://schemas.openxmlformats.org/drawingml/2006/main">
+<ns0:sld xmlns:a="http://schemas.openxmlformats.org/drawingml/2006/main" xmlns:ns0="http://schemas.openxmlformats.org/presentationml/2006/main" xmlns:ns2="http://schemas.microsoft.com/office/drawing/2014/main" xmlns:ns3="http://schemas.microsoft.com/office/powerpoint/2010/main">
+  <ns0:cSld>
+    <ns0:spTree>
+      <ns0:nvGrpSpPr>
+        <ns0:cNvPr id="1" name=""/>
+        <ns0:cNvGrpSpPr/>
+        <ns0:nvPr/>
+      </ns0:nvGrpSpPr>
+      <ns0:grpSpPr>
+        <a:xfrm/>
+      </ns0:grpSpPr>
+      <ns0:sp>
+        <ns0:nvSpPr>
+          <ns0:cNvPr id="1" name="">
+            <a:extLst>
+              <a:ext uri="{FF2B5EF4-FFF2-40B4-BE49-F238E27FC236}">
+                <ns2:creationId id="{72FAC77F-4EE2-4380-B9AF-C3F39077ECED}"/>
+              </a:ext>
+            </a:extLst>
+          </ns0:cNvPr>
+          <ns0:cNvSpPr>
+            <a:spLocks noGrp="1"/>
+          </ns0:cNvSpPr>
+          <ns0:nvPr/>
+        </ns0:nvSpPr>
+        <ns0:spPr>
+          <a:xfrm>
             <a:off x="0" y="0"/>
             <a:ext cx="12192000" cy="6858000"/>
           </a:xfrm>
-          <a:prstGeom xmlns:a="http://schemas.openxmlformats.org/drawingml/2006/main" prst="rect">
-            <a:avLst/>
-          </a:prstGeom>
-          <a:solidFill xmlns:a="http://schemas.openxmlformats.org/drawingml/2006/main">
+          <a:prstGeom prst="rect">
+            <a:avLst/>
+          </a:prstGeom>
+          <a:solidFill>
             <a:srgbClr val="F6F3EA"/>
           </a:solidFill>
-          <a:ln xmlns:a="http://schemas.openxmlformats.org/drawingml/2006/main" w="0">
-            <a:solidFill>
-              <a:srgbClr val="000000">
-                <a:alpha val="0"/>
-              </a:srgbClr>
-            </a:solidFill>
-            <a:prstDash val="solid"/>
-          </a:ln>
-        </p:spPr>
-      </p:sp>
-      <p:sp>
-        <p:nvSpPr>
-          <p:cNvPr id="2" name="">
-            <a:extLst xmlns:a="http://schemas.openxmlformats.org/drawingml/2006/main">
-              <a:ext uri="{FF2B5EF4-FFF2-40B4-BE49-F238E27FC236}">
-                <a16:creationId xmlns:a16="http://schemas.microsoft.com/office/drawing/2014/main" id="{62ADC30B-23BB-414B-8479-BBCB4B2702CB}"/>
-              </a:ext>
-            </a:extLst>
-          </p:cNvPr>
-          <p:cNvSpPr>
-            <a:spLocks xmlns:a="http://schemas.openxmlformats.org/drawingml/2006/main" noGrp="1"/>
-          </p:cNvSpPr>
-          <p:nvPr/>
-        </p:nvSpPr>
-        <p:spPr>
-          <a:xfrm xmlns:a="http://schemas.openxmlformats.org/drawingml/2006/main">
+          <a:ln w="0">
+            <a:solidFill>
+              <a:srgbClr val="000000">
+                <a:alpha val="0"/>
+              </a:srgbClr>
+            </a:solidFill>
+            <a:prstDash val="solid"/>
+          </a:ln>
+        </ns0:spPr>
+      </ns0:sp>
+      <ns0:sp>
+        <ns0:nvSpPr>
+          <ns0:cNvPr id="2" name="">
+            <a:extLst>
+              <a:ext uri="{FF2B5EF4-FFF2-40B4-BE49-F238E27FC236}">
+                <ns2:creationId id="{62ADC30B-23BB-414B-8479-BBCB4B2702CB}"/>
+              </a:ext>
+            </a:extLst>
+          </ns0:cNvPr>
+          <ns0:cNvSpPr>
+            <a:spLocks noGrp="1"/>
+          </ns0:cNvSpPr>
+          <ns0:nvPr/>
+        </ns0:nvSpPr>
+        <ns0:spPr>
+          <a:xfrm>
             <a:off x="0" y="0"/>
             <a:ext cx="228600" cy="6858000"/>
           </a:xfrm>
-          <a:prstGeom xmlns:a="http://schemas.openxmlformats.org/drawingml/2006/main" prst="rect">
-            <a:avLst/>
-          </a:prstGeom>
-          <a:solidFill xmlns:a="http://schemas.openxmlformats.org/drawingml/2006/main">
+          <a:prstGeom prst="rect">
+            <a:avLst/>
+          </a:prstGeom>
+          <a:solidFill>
             <a:srgbClr val="2E6B45"/>
           </a:solidFill>
-          <a:ln xmlns:a="http://schemas.openxmlformats.org/drawingml/2006/main" w="0">
-            <a:solidFill>
-              <a:srgbClr val="000000">
-                <a:alpha val="0"/>
-              </a:srgbClr>
-            </a:solidFill>
-            <a:prstDash val="solid"/>
-          </a:ln>
-        </p:spPr>
-      </p:sp>
-      <p:sp>
-        <p:nvSpPr>
-          <p:cNvPr id="3" name="">
-            <a:extLst xmlns:a="http://schemas.openxmlformats.org/drawingml/2006/main">
-              <a:ext uri="{FF2B5EF4-FFF2-40B4-BE49-F238E27FC236}">
-                <a16:creationId xmlns:a16="http://schemas.microsoft.com/office/drawing/2014/main" id="{00BD40A0-7C28-4A19-9320-35CC8E9EA832}"/>
-              </a:ext>
-            </a:extLst>
-          </p:cNvPr>
-          <p:cNvSpPr>
-            <a:spLocks xmlns:a="http://schemas.openxmlformats.org/drawingml/2006/main" noGrp="1"/>
-          </p:cNvSpPr>
-          <p:nvPr/>
-        </p:nvSpPr>
-        <p:spPr>
-          <a:xfrm xmlns:a="http://schemas.openxmlformats.org/drawingml/2006/main">
+          <a:ln w="0">
+            <a:solidFill>
+              <a:srgbClr val="000000">
+                <a:alpha val="0"/>
+              </a:srgbClr>
+            </a:solidFill>
+            <a:prstDash val="solid"/>
+          </a:ln>
+        </ns0:spPr>
+      </ns0:sp>
+      <ns0:sp>
+        <ns0:nvSpPr>
+          <ns0:cNvPr id="3" name="">
+            <a:extLst>
+              <a:ext uri="{FF2B5EF4-FFF2-40B4-BE49-F238E27FC236}">
+                <ns2:creationId id="{00BD40A0-7C28-4A19-9320-35CC8E9EA832}"/>
+              </a:ext>
+            </a:extLst>
+          </ns0:cNvPr>
+          <ns0:cNvSpPr>
+            <a:spLocks noGrp="1"/>
+          </ns0:cNvSpPr>
+          <ns0:nvPr/>
+        </ns0:nvSpPr>
+        <ns0:spPr>
+          <a:xfrm>
             <a:off x="11049000" y="6191250"/>
             <a:ext cx="762000" cy="209550"/>
           </a:xfrm>
-          <a:prstGeom xmlns:a="http://schemas.openxmlformats.org/drawingml/2006/main" prst="rect">
-            <a:avLst/>
-          </a:prstGeom>
-          <a:solidFill xmlns:a="http://schemas.openxmlformats.org/drawingml/2006/main">
-            <a:srgbClr val="000000">
-              <a:alpha val="0"/>
-            </a:srgbClr>
-          </a:solidFill>
-          <a:ln xmlns:a="http://schemas.openxmlformats.org/drawingml/2006/main" w="0">
-            <a:solidFill>
-              <a:srgbClr val="000000">
-                <a:alpha val="0"/>
-              </a:srgbClr>
-            </a:solidFill>
-            <a:prstDash val="solid"/>
-          </a:ln>
-        </p:spPr>
-        <p:txBody>
-          <a:bodyPr xmlns:a="http://schemas.openxmlformats.org/drawingml/2006/main" lIns="0" tIns="0" rIns="0" bIns="0" anchor="t"/>
-          <a:lstStyle xmlns:a="http://schemas.openxmlformats.org/drawingml/2006/main"/>
-          <a:p xmlns:a="http://schemas.openxmlformats.org/drawingml/2006/main">
+          <a:prstGeom prst="rect">
+            <a:avLst/>
+          </a:prstGeom>
+          <a:solidFill>
+            <a:srgbClr val="000000">
+              <a:alpha val="0"/>
+            </a:srgbClr>
+          </a:solidFill>
+          <a:ln w="0">
+            <a:solidFill>
+              <a:srgbClr val="000000">
+                <a:alpha val="0"/>
+              </a:srgbClr>
+            </a:solidFill>
+            <a:prstDash val="solid"/>
+          </a:ln>
+        </ns0:spPr>
+        <ns0:txBody>
+          <a:bodyPr lIns="0" tIns="0" rIns="0" bIns="0" anchor="t"/>
+          <a:lstStyle/>
+          <a:p>
             <a:pPr algn="r">
               <a:defRPr sz="900" b="0">
                 <a:solidFill>
@@ -6797,48 +6797,48 @@
               <a:t>12</a:t>
             </a:r>
           </a:p>
-        </p:txBody>
-      </p:sp>
-      <p:sp>
-        <p:nvSpPr>
-          <p:cNvPr id="4" name="">
-            <a:extLst xmlns:a="http://schemas.openxmlformats.org/drawingml/2006/main">
-              <a:ext uri="{FF2B5EF4-FFF2-40B4-BE49-F238E27FC236}">
-                <a16:creationId xmlns:a16="http://schemas.microsoft.com/office/drawing/2014/main" id="{65BD3DF1-2A0D-4403-AE72-8D23DB087E3A}"/>
-              </a:ext>
-            </a:extLst>
-          </p:cNvPr>
-          <p:cNvSpPr>
-            <a:spLocks xmlns:a="http://schemas.openxmlformats.org/drawingml/2006/main" noGrp="1"/>
-          </p:cNvSpPr>
-          <p:nvPr/>
-        </p:nvSpPr>
-        <p:spPr>
-          <a:xfrm xmlns:a="http://schemas.openxmlformats.org/drawingml/2006/main">
+        </ns0:txBody>
+      </ns0:sp>
+      <ns0:sp>
+        <ns0:nvSpPr>
+          <ns0:cNvPr id="4" name="">
+            <a:extLst>
+              <a:ext uri="{FF2B5EF4-FFF2-40B4-BE49-F238E27FC236}">
+                <ns2:creationId id="{65BD3DF1-2A0D-4403-AE72-8D23DB087E3A}"/>
+              </a:ext>
+            </a:extLst>
+          </ns0:cNvPr>
+          <ns0:cNvSpPr>
+            <a:spLocks noGrp="1"/>
+          </ns0:cNvSpPr>
+          <ns0:nvPr/>
+        </ns0:nvSpPr>
+        <ns0:spPr>
+          <a:xfrm>
             <a:off x="685800" y="400050"/>
             <a:ext cx="8763000" cy="228600"/>
           </a:xfrm>
-          <a:prstGeom xmlns:a="http://schemas.openxmlformats.org/drawingml/2006/main" prst="rect">
-            <a:avLst/>
-          </a:prstGeom>
-          <a:solidFill xmlns:a="http://schemas.openxmlformats.org/drawingml/2006/main">
-            <a:srgbClr val="000000">
-              <a:alpha val="0"/>
-            </a:srgbClr>
-          </a:solidFill>
-          <a:ln xmlns:a="http://schemas.openxmlformats.org/drawingml/2006/main" w="0">
-            <a:solidFill>
-              <a:srgbClr val="000000">
-                <a:alpha val="0"/>
-              </a:srgbClr>
-            </a:solidFill>
-            <a:prstDash val="solid"/>
-          </a:ln>
-        </p:spPr>
-        <p:txBody>
-          <a:bodyPr xmlns:a="http://schemas.openxmlformats.org/drawingml/2006/main" lIns="0" tIns="0" rIns="0" bIns="0" anchor="t"/>
-          <a:lstStyle xmlns:a="http://schemas.openxmlformats.org/drawingml/2006/main"/>
-          <a:p xmlns:a="http://schemas.openxmlformats.org/drawingml/2006/main">
+          <a:prstGeom prst="rect">
+            <a:avLst/>
+          </a:prstGeom>
+          <a:solidFill>
+            <a:srgbClr val="000000">
+              <a:alpha val="0"/>
+            </a:srgbClr>
+          </a:solidFill>
+          <a:ln w="0">
+            <a:solidFill>
+              <a:srgbClr val="000000">
+                <a:alpha val="0"/>
+              </a:srgbClr>
+            </a:solidFill>
+            <a:prstDash val="solid"/>
+          </a:ln>
+        </ns0:spPr>
+        <ns0:txBody>
+          <a:bodyPr lIns="0" tIns="0" rIns="0" bIns="0" anchor="t"/>
+          <a:lstStyle/>
+          <a:p>
             <a:pPr algn="l">
               <a:defRPr sz="900" b="1">
                 <a:solidFill>
@@ -6861,48 +6861,48 @@
               <a:t>RESULTADOS DE LA DEMO</a:t>
             </a:r>
           </a:p>
-        </p:txBody>
-      </p:sp>
-      <p:sp>
-        <p:nvSpPr>
-          <p:cNvPr id="5" name="">
-            <a:extLst xmlns:a="http://schemas.openxmlformats.org/drawingml/2006/main">
-              <a:ext uri="{FF2B5EF4-FFF2-40B4-BE49-F238E27FC236}">
-                <a16:creationId xmlns:a16="http://schemas.microsoft.com/office/drawing/2014/main" id="{75F7F912-B714-4904-9BE6-34C975B31B6D}"/>
-              </a:ext>
-            </a:extLst>
-          </p:cNvPr>
-          <p:cNvSpPr>
-            <a:spLocks xmlns:a="http://schemas.openxmlformats.org/drawingml/2006/main" noGrp="1"/>
-          </p:cNvSpPr>
-          <p:nvPr/>
-        </p:nvSpPr>
-        <p:spPr>
-          <a:xfrm xmlns:a="http://schemas.openxmlformats.org/drawingml/2006/main">
+        </ns0:txBody>
+      </ns0:sp>
+      <ns0:sp>
+        <ns0:nvSpPr>
+          <ns0:cNvPr id="5" name="">
+            <a:extLst>
+              <a:ext uri="{FF2B5EF4-FFF2-40B4-BE49-F238E27FC236}">
+                <ns2:creationId id="{75F7F912-B714-4904-9BE6-34C975B31B6D}"/>
+              </a:ext>
+            </a:extLst>
+          </ns0:cNvPr>
+          <ns0:cNvSpPr>
+            <a:spLocks noGrp="1"/>
+          </ns0:cNvSpPr>
+          <ns0:nvPr/>
+        </ns0:nvSpPr>
+        <ns0:spPr>
+          <a:xfrm>
             <a:off x="685800" y="685800"/>
             <a:ext cx="9906000" cy="876300"/>
           </a:xfrm>
-          <a:prstGeom xmlns:a="http://schemas.openxmlformats.org/drawingml/2006/main" prst="rect">
-            <a:avLst/>
-          </a:prstGeom>
-          <a:solidFill xmlns:a="http://schemas.openxmlformats.org/drawingml/2006/main">
-            <a:srgbClr val="000000">
-              <a:alpha val="0"/>
-            </a:srgbClr>
-          </a:solidFill>
-          <a:ln xmlns:a="http://schemas.openxmlformats.org/drawingml/2006/main" w="0">
-            <a:solidFill>
-              <a:srgbClr val="000000">
-                <a:alpha val="0"/>
-              </a:srgbClr>
-            </a:solidFill>
-            <a:prstDash val="solid"/>
-          </a:ln>
-        </p:spPr>
-        <p:txBody>
-          <a:bodyPr xmlns:a="http://schemas.openxmlformats.org/drawingml/2006/main" lIns="0" tIns="0" rIns="0" bIns="0" anchor="t"/>
-          <a:lstStyle xmlns:a="http://schemas.openxmlformats.org/drawingml/2006/main"/>
-          <a:p xmlns:a="http://schemas.openxmlformats.org/drawingml/2006/main">
+          <a:prstGeom prst="rect">
+            <a:avLst/>
+          </a:prstGeom>
+          <a:solidFill>
+            <a:srgbClr val="000000">
+              <a:alpha val="0"/>
+            </a:srgbClr>
+          </a:solidFill>
+          <a:ln w="0">
+            <a:solidFill>
+              <a:srgbClr val="000000">
+                <a:alpha val="0"/>
+              </a:srgbClr>
+            </a:solidFill>
+            <a:prstDash val="solid"/>
+          </a:ln>
+        </ns0:spPr>
+        <ns0:txBody>
+          <a:bodyPr lIns="0" tIns="0" rIns="0" bIns="0" anchor="t"/>
+          <a:lstStyle/>
+          <a:p>
             <a:pPr algn="l">
               <a:defRPr sz="2550" b="1">
                 <a:solidFill>
@@ -6925,48 +6925,48 @@
               <a:t>El prototipo devuelve una recomendación cuantificada para la parcela completa.</a:t>
             </a:r>
           </a:p>
-        </p:txBody>
-      </p:sp>
-      <p:sp>
-        <p:nvSpPr>
-          <p:cNvPr id="6" name="">
-            <a:extLst xmlns:a="http://schemas.openxmlformats.org/drawingml/2006/main">
-              <a:ext uri="{FF2B5EF4-FFF2-40B4-BE49-F238E27FC236}">
-                <a16:creationId xmlns:a16="http://schemas.microsoft.com/office/drawing/2014/main" id="{E16D3567-AC57-4060-8839-247044BC3773}"/>
-              </a:ext>
-            </a:extLst>
-          </p:cNvPr>
-          <p:cNvSpPr>
-            <a:spLocks xmlns:a="http://schemas.openxmlformats.org/drawingml/2006/main" noGrp="1"/>
-          </p:cNvSpPr>
-          <p:nvPr/>
-        </p:nvSpPr>
-        <p:spPr>
-          <a:xfrm xmlns:a="http://schemas.openxmlformats.org/drawingml/2006/main">
+        </ns0:txBody>
+      </ns0:sp>
+      <ns0:sp>
+        <ns0:nvSpPr>
+          <ns0:cNvPr id="6" name="">
+            <a:extLst>
+              <a:ext uri="{FF2B5EF4-FFF2-40B4-BE49-F238E27FC236}">
+                <ns2:creationId id="{E16D3567-AC57-4060-8839-247044BC3773}"/>
+              </a:ext>
+            </a:extLst>
+          </ns0:cNvPr>
+          <ns0:cNvSpPr>
+            <a:spLocks noGrp="1"/>
+          </ns0:cNvSpPr>
+          <ns0:nvPr/>
+        </ns0:nvSpPr>
+        <ns0:spPr>
+          <a:xfrm>
             <a:off x="685800" y="1428750"/>
             <a:ext cx="9334500" cy="533400"/>
           </a:xfrm>
-          <a:prstGeom xmlns:a="http://schemas.openxmlformats.org/drawingml/2006/main" prst="rect">
-            <a:avLst/>
-          </a:prstGeom>
-          <a:solidFill xmlns:a="http://schemas.openxmlformats.org/drawingml/2006/main">
-            <a:srgbClr val="000000">
-              <a:alpha val="0"/>
-            </a:srgbClr>
-          </a:solidFill>
-          <a:ln xmlns:a="http://schemas.openxmlformats.org/drawingml/2006/main" w="0">
-            <a:solidFill>
-              <a:srgbClr val="000000">
-                <a:alpha val="0"/>
-              </a:srgbClr>
-            </a:solidFill>
-            <a:prstDash val="solid"/>
-          </a:ln>
-        </p:spPr>
-        <p:txBody>
-          <a:bodyPr xmlns:a="http://schemas.openxmlformats.org/drawingml/2006/main" lIns="0" tIns="0" rIns="0" bIns="0" anchor="t"/>
-          <a:lstStyle xmlns:a="http://schemas.openxmlformats.org/drawingml/2006/main"/>
-          <a:p xmlns:a="http://schemas.openxmlformats.org/drawingml/2006/main">
+          <a:prstGeom prst="rect">
+            <a:avLst/>
+          </a:prstGeom>
+          <a:solidFill>
+            <a:srgbClr val="000000">
+              <a:alpha val="0"/>
+            </a:srgbClr>
+          </a:solidFill>
+          <a:ln w="0">
+            <a:solidFill>
+              <a:srgbClr val="000000">
+                <a:alpha val="0"/>
+              </a:srgbClr>
+            </a:solidFill>
+            <a:prstDash val="solid"/>
+          </a:ln>
+        </ns0:spPr>
+        <ns0:txBody>
+          <a:bodyPr lIns="0" tIns="0" rIns="0" bIns="0" anchor="t"/>
+          <a:lstStyle/>
+          <a:p>
             <a:pPr algn="l">
               <a:defRPr sz="1350" b="0">
                 <a:solidFill>
@@ -6986,84 +6986,84 @@
                 <a:ea typeface="Aptos"/>
                 <a:cs typeface="Aptos"/>
               </a:rPr>
-              <a:t>Los indicadores se expresan en unidades comprensibles para la toma de decisiónes.</a:t>
-            </a:r>
-          </a:p>
-        </p:txBody>
-      </p:sp>
-      <p:sp>
-        <p:nvSpPr>
-          <p:cNvPr id="7" name="">
-            <a:extLst xmlns:a="http://schemas.openxmlformats.org/drawingml/2006/main">
-              <a:ext uri="{FF2B5EF4-FFF2-40B4-BE49-F238E27FC236}">
-                <a16:creationId xmlns:a16="http://schemas.microsoft.com/office/drawing/2014/main" id="{52B43342-4AC3-48D1-8AC9-EF78C1ECD3A6}"/>
-              </a:ext>
-            </a:extLst>
-          </p:cNvPr>
-          <p:cNvSpPr>
-            <a:spLocks xmlns:a="http://schemas.openxmlformats.org/drawingml/2006/main" noGrp="1"/>
-          </p:cNvSpPr>
-          <p:nvPr/>
-        </p:nvSpPr>
-        <p:spPr>
-          <a:xfrm xmlns:a="http://schemas.openxmlformats.org/drawingml/2006/main">
+              <a:t>Los indicadores se expresan en unidades comprensibles para la toma de decisiones.</a:t>
+            </a:r>
+          </a:p>
+        </ns0:txBody>
+      </ns0:sp>
+      <ns0:sp>
+        <ns0:nvSpPr>
+          <ns0:cNvPr id="7" name="">
+            <a:extLst>
+              <a:ext uri="{FF2B5EF4-FFF2-40B4-BE49-F238E27FC236}">
+                <ns2:creationId id="{52B43342-4AC3-48D1-8AC9-EF78C1ECD3A6}"/>
+              </a:ext>
+            </a:extLst>
+          </ns0:cNvPr>
+          <ns0:cNvSpPr>
+            <a:spLocks noGrp="1"/>
+          </ns0:cNvSpPr>
+          <ns0:nvPr/>
+        </ns0:nvSpPr>
+        <ns0:spPr>
+          <a:xfrm>
             <a:off x="685800" y="2266950"/>
             <a:ext cx="2333625" cy="1104900"/>
           </a:xfrm>
-          <a:prstGeom xmlns:a="http://schemas.openxmlformats.org/drawingml/2006/main" prst="rect">
-            <a:avLst/>
-          </a:prstGeom>
-          <a:solidFill xmlns:a="http://schemas.openxmlformats.org/drawingml/2006/main">
+          <a:prstGeom prst="rect">
+            <a:avLst/>
+          </a:prstGeom>
+          <a:solidFill>
             <a:srgbClr val="FFFFFF"/>
           </a:solidFill>
-          <a:ln xmlns:a="http://schemas.openxmlformats.org/drawingml/2006/main" w="9525">
+          <a:ln w="9525">
             <a:solidFill>
               <a:srgbClr val="CBD5C7"/>
             </a:solidFill>
             <a:prstDash val="solid"/>
           </a:ln>
-        </p:spPr>
-      </p:sp>
-      <p:sp>
-        <p:nvSpPr>
-          <p:cNvPr id="8" name="">
-            <a:extLst xmlns:a="http://schemas.openxmlformats.org/drawingml/2006/main">
-              <a:ext uri="{FF2B5EF4-FFF2-40B4-BE49-F238E27FC236}">
-                <a16:creationId xmlns:a16="http://schemas.microsoft.com/office/drawing/2014/main" id="{0A3C6B97-2203-459F-B548-56F0591FA8B8}"/>
-              </a:ext>
-            </a:extLst>
-          </p:cNvPr>
-          <p:cNvSpPr>
-            <a:spLocks xmlns:a="http://schemas.openxmlformats.org/drawingml/2006/main" noGrp="1"/>
-          </p:cNvSpPr>
-          <p:nvPr/>
-        </p:nvSpPr>
-        <p:spPr>
-          <a:xfrm xmlns:a="http://schemas.openxmlformats.org/drawingml/2006/main">
+        </ns0:spPr>
+      </ns0:sp>
+      <ns0:sp>
+        <ns0:nvSpPr>
+          <ns0:cNvPr id="8" name="">
+            <a:extLst>
+              <a:ext uri="{FF2B5EF4-FFF2-40B4-BE49-F238E27FC236}">
+                <ns2:creationId id="{0A3C6B97-2203-459F-B548-56F0591FA8B8}"/>
+              </a:ext>
+            </a:extLst>
+          </ns0:cNvPr>
+          <ns0:cNvSpPr>
+            <a:spLocks noGrp="1"/>
+          </ns0:cNvSpPr>
+          <ns0:nvPr/>
+        </ns0:nvSpPr>
+        <ns0:spPr>
+          <a:xfrm>
             <a:off x="857250" y="2419350"/>
             <a:ext cx="1990725" cy="171450"/>
           </a:xfrm>
-          <a:prstGeom xmlns:a="http://schemas.openxmlformats.org/drawingml/2006/main" prst="rect">
-            <a:avLst/>
-          </a:prstGeom>
-          <a:solidFill xmlns:a="http://schemas.openxmlformats.org/drawingml/2006/main">
-            <a:srgbClr val="000000">
-              <a:alpha val="0"/>
-            </a:srgbClr>
-          </a:solidFill>
-          <a:ln xmlns:a="http://schemas.openxmlformats.org/drawingml/2006/main" w="0">
-            <a:solidFill>
-              <a:srgbClr val="000000">
-                <a:alpha val="0"/>
-              </a:srgbClr>
-            </a:solidFill>
-            <a:prstDash val="solid"/>
-          </a:ln>
-        </p:spPr>
-        <p:txBody>
-          <a:bodyPr xmlns:a="http://schemas.openxmlformats.org/drawingml/2006/main" lIns="0" tIns="0" rIns="0" bIns="0" anchor="t"/>
-          <a:lstStyle xmlns:a="http://schemas.openxmlformats.org/drawingml/2006/main"/>
-          <a:p xmlns:a="http://schemas.openxmlformats.org/drawingml/2006/main">
+          <a:prstGeom prst="rect">
+            <a:avLst/>
+          </a:prstGeom>
+          <a:solidFill>
+            <a:srgbClr val="000000">
+              <a:alpha val="0"/>
+            </a:srgbClr>
+          </a:solidFill>
+          <a:ln w="0">
+            <a:solidFill>
+              <a:srgbClr val="000000">
+                <a:alpha val="0"/>
+              </a:srgbClr>
+            </a:solidFill>
+            <a:prstDash val="solid"/>
+          </a:ln>
+        </ns0:spPr>
+        <ns0:txBody>
+          <a:bodyPr lIns="0" tIns="0" rIns="0" bIns="0" anchor="t"/>
+          <a:lstStyle/>
+          <a:p>
             <a:pPr algn="l">
               <a:defRPr sz="975" b="1">
                 <a:solidFill>
@@ -7086,48 +7086,48 @@
               <a:t>Riego total del periodo</a:t>
             </a:r>
           </a:p>
-        </p:txBody>
-      </p:sp>
-      <p:sp>
-        <p:nvSpPr>
-          <p:cNvPr id="9" name="">
-            <a:extLst xmlns:a="http://schemas.openxmlformats.org/drawingml/2006/main">
-              <a:ext uri="{FF2B5EF4-FFF2-40B4-BE49-F238E27FC236}">
-                <a16:creationId xmlns:a16="http://schemas.microsoft.com/office/drawing/2014/main" id="{04D79712-0DE2-4B4E-9B79-C1BDD80AA63B}"/>
-              </a:ext>
-            </a:extLst>
-          </p:cNvPr>
-          <p:cNvSpPr>
-            <a:spLocks xmlns:a="http://schemas.openxmlformats.org/drawingml/2006/main" noGrp="1"/>
-          </p:cNvSpPr>
-          <p:nvPr/>
-        </p:nvSpPr>
-        <p:spPr>
-          <a:xfrm xmlns:a="http://schemas.openxmlformats.org/drawingml/2006/main">
+        </ns0:txBody>
+      </ns0:sp>
+      <ns0:sp>
+        <ns0:nvSpPr>
+          <ns0:cNvPr id="9" name="">
+            <a:extLst>
+              <a:ext uri="{FF2B5EF4-FFF2-40B4-BE49-F238E27FC236}">
+                <ns2:creationId id="{04D79712-0DE2-4B4E-9B79-C1BDD80AA63B}"/>
+              </a:ext>
+            </a:extLst>
+          </ns0:cNvPr>
+          <ns0:cNvSpPr>
+            <a:spLocks noGrp="1"/>
+          </ns0:cNvSpPr>
+          <ns0:nvPr/>
+        </ns0:nvSpPr>
+        <ns0:spPr>
+          <a:xfrm>
             <a:off x="857250" y="2647950"/>
             <a:ext cx="1990725" cy="400050"/>
           </a:xfrm>
-          <a:prstGeom xmlns:a="http://schemas.openxmlformats.org/drawingml/2006/main" prst="rect">
-            <a:avLst/>
-          </a:prstGeom>
-          <a:solidFill xmlns:a="http://schemas.openxmlformats.org/drawingml/2006/main">
-            <a:srgbClr val="000000">
-              <a:alpha val="0"/>
-            </a:srgbClr>
-          </a:solidFill>
-          <a:ln xmlns:a="http://schemas.openxmlformats.org/drawingml/2006/main" w="0">
-            <a:solidFill>
-              <a:srgbClr val="000000">
-                <a:alpha val="0"/>
-              </a:srgbClr>
-            </a:solidFill>
-            <a:prstDash val="solid"/>
-          </a:ln>
-        </p:spPr>
-        <p:txBody>
-          <a:bodyPr xmlns:a="http://schemas.openxmlformats.org/drawingml/2006/main" lIns="0" tIns="0" rIns="0" bIns="0" anchor="t"/>
-          <a:lstStyle xmlns:a="http://schemas.openxmlformats.org/drawingml/2006/main"/>
-          <a:p xmlns:a="http://schemas.openxmlformats.org/drawingml/2006/main">
+          <a:prstGeom prst="rect">
+            <a:avLst/>
+          </a:prstGeom>
+          <a:solidFill>
+            <a:srgbClr val="000000">
+              <a:alpha val="0"/>
+            </a:srgbClr>
+          </a:solidFill>
+          <a:ln w="0">
+            <a:solidFill>
+              <a:srgbClr val="000000">
+                <a:alpha val="0"/>
+              </a:srgbClr>
+            </a:solidFill>
+            <a:prstDash val="solid"/>
+          </a:ln>
+        </ns0:spPr>
+        <ns0:txBody>
+          <a:bodyPr lIns="0" tIns="0" rIns="0" bIns="0" anchor="t"/>
+          <a:lstStyle/>
+          <a:p>
             <a:pPr algn="l">
               <a:defRPr sz="2175" b="1">
                 <a:solidFill>
@@ -7150,48 +7150,48 @@
               <a:t>97.156 L</a:t>
             </a:r>
           </a:p>
-        </p:txBody>
-      </p:sp>
-      <p:sp>
-        <p:nvSpPr>
-          <p:cNvPr id="10" name="">
-            <a:extLst xmlns:a="http://schemas.openxmlformats.org/drawingml/2006/main">
-              <a:ext uri="{FF2B5EF4-FFF2-40B4-BE49-F238E27FC236}">
-                <a16:creationId xmlns:a16="http://schemas.microsoft.com/office/drawing/2014/main" id="{36D8A12A-4334-4F12-9F78-7D27EE1C1DF6}"/>
-              </a:ext>
-            </a:extLst>
-          </p:cNvPr>
-          <p:cNvSpPr>
-            <a:spLocks xmlns:a="http://schemas.openxmlformats.org/drawingml/2006/main" noGrp="1"/>
-          </p:cNvSpPr>
-          <p:nvPr/>
-        </p:nvSpPr>
-        <p:spPr>
-          <a:xfrm xmlns:a="http://schemas.openxmlformats.org/drawingml/2006/main">
+        </ns0:txBody>
+      </ns0:sp>
+      <ns0:sp>
+        <ns0:nvSpPr>
+          <ns0:cNvPr id="10" name="">
+            <a:extLst>
+              <a:ext uri="{FF2B5EF4-FFF2-40B4-BE49-F238E27FC236}">
+                <ns2:creationId id="{36D8A12A-4334-4F12-9F78-7D27EE1C1DF6}"/>
+              </a:ext>
+            </a:extLst>
+          </ns0:cNvPr>
+          <ns0:cNvSpPr>
+            <a:spLocks noGrp="1"/>
+          </ns0:cNvSpPr>
+          <ns0:nvPr/>
+        </ns0:nvSpPr>
+        <ns0:spPr>
+          <a:xfrm>
             <a:off x="857250" y="3086100"/>
             <a:ext cx="1990725" cy="266700"/>
           </a:xfrm>
-          <a:prstGeom xmlns:a="http://schemas.openxmlformats.org/drawingml/2006/main" prst="rect">
-            <a:avLst/>
-          </a:prstGeom>
-          <a:solidFill xmlns:a="http://schemas.openxmlformats.org/drawingml/2006/main">
-            <a:srgbClr val="000000">
-              <a:alpha val="0"/>
-            </a:srgbClr>
-          </a:solidFill>
-          <a:ln xmlns:a="http://schemas.openxmlformats.org/drawingml/2006/main" w="0">
-            <a:solidFill>
-              <a:srgbClr val="000000">
-                <a:alpha val="0"/>
-              </a:srgbClr>
-            </a:solidFill>
-            <a:prstDash val="solid"/>
-          </a:ln>
-        </p:spPr>
-        <p:txBody>
-          <a:bodyPr xmlns:a="http://schemas.openxmlformats.org/drawingml/2006/main" lIns="0" tIns="0" rIns="0" bIns="0" anchor="t"/>
-          <a:lstStyle xmlns:a="http://schemas.openxmlformats.org/drawingml/2006/main"/>
-          <a:p xmlns:a="http://schemas.openxmlformats.org/drawingml/2006/main">
+          <a:prstGeom prst="rect">
+            <a:avLst/>
+          </a:prstGeom>
+          <a:solidFill>
+            <a:srgbClr val="000000">
+              <a:alpha val="0"/>
+            </a:srgbClr>
+          </a:solidFill>
+          <a:ln w="0">
+            <a:solidFill>
+              <a:srgbClr val="000000">
+                <a:alpha val="0"/>
+              </a:srgbClr>
+            </a:solidFill>
+            <a:prstDash val="solid"/>
+          </a:ln>
+        </ns0:spPr>
+        <ns0:txBody>
+          <a:bodyPr lIns="0" tIns="0" rIns="0" bIns="0" anchor="t"/>
+          <a:lstStyle/>
+          <a:p>
             <a:pPr algn="l">
               <a:defRPr sz="900" b="0">
                 <a:solidFill>
@@ -7214,81 +7214,81 @@
               <a:t>Agua total recomendada para los siete días.</a:t>
             </a:r>
           </a:p>
-        </p:txBody>
-      </p:sp>
-      <p:sp>
-        <p:nvSpPr>
-          <p:cNvPr id="11" name="">
-            <a:extLst xmlns:a="http://schemas.openxmlformats.org/drawingml/2006/main">
-              <a:ext uri="{FF2B5EF4-FFF2-40B4-BE49-F238E27FC236}">
-                <a16:creationId xmlns:a16="http://schemas.microsoft.com/office/drawing/2014/main" id="{A7FBCDE2-B91A-4EEE-9057-4D2C71BE5D9A}"/>
-              </a:ext>
-            </a:extLst>
-          </p:cNvPr>
-          <p:cNvSpPr>
-            <a:spLocks xmlns:a="http://schemas.openxmlformats.org/drawingml/2006/main" noGrp="1"/>
-          </p:cNvSpPr>
-          <p:nvPr/>
-        </p:nvSpPr>
-        <p:spPr>
-          <a:xfrm xmlns:a="http://schemas.openxmlformats.org/drawingml/2006/main">
+        </ns0:txBody>
+      </ns0:sp>
+      <ns0:sp>
+        <ns0:nvSpPr>
+          <ns0:cNvPr id="11" name="">
+            <a:extLst>
+              <a:ext uri="{FF2B5EF4-FFF2-40B4-BE49-F238E27FC236}">
+                <ns2:creationId id="{A7FBCDE2-B91A-4EEE-9057-4D2C71BE5D9A}"/>
+              </a:ext>
+            </a:extLst>
+          </ns0:cNvPr>
+          <ns0:cNvSpPr>
+            <a:spLocks noGrp="1"/>
+          </ns0:cNvSpPr>
+          <ns0:nvPr/>
+        </ns0:nvSpPr>
+        <ns0:spPr>
+          <a:xfrm>
             <a:off x="3352800" y="2266950"/>
             <a:ext cx="2333625" cy="1104900"/>
           </a:xfrm>
-          <a:prstGeom xmlns:a="http://schemas.openxmlformats.org/drawingml/2006/main" prst="rect">
-            <a:avLst/>
-          </a:prstGeom>
-          <a:solidFill xmlns:a="http://schemas.openxmlformats.org/drawingml/2006/main">
+          <a:prstGeom prst="rect">
+            <a:avLst/>
+          </a:prstGeom>
+          <a:solidFill>
             <a:srgbClr val="FFFFFF"/>
           </a:solidFill>
-          <a:ln xmlns:a="http://schemas.openxmlformats.org/drawingml/2006/main" w="9525">
+          <a:ln w="9525">
             <a:solidFill>
               <a:srgbClr val="CBD5C7"/>
             </a:solidFill>
             <a:prstDash val="solid"/>
           </a:ln>
-        </p:spPr>
-      </p:sp>
-      <p:sp>
-        <p:nvSpPr>
-          <p:cNvPr id="12" name="">
-            <a:extLst xmlns:a="http://schemas.openxmlformats.org/drawingml/2006/main">
-              <a:ext uri="{FF2B5EF4-FFF2-40B4-BE49-F238E27FC236}">
-                <a16:creationId xmlns:a16="http://schemas.microsoft.com/office/drawing/2014/main" id="{2A7532DB-EEDB-4682-BFDE-D872D8787FC2}"/>
-              </a:ext>
-            </a:extLst>
-          </p:cNvPr>
-          <p:cNvSpPr>
-            <a:spLocks xmlns:a="http://schemas.openxmlformats.org/drawingml/2006/main" noGrp="1"/>
-          </p:cNvSpPr>
-          <p:nvPr/>
-        </p:nvSpPr>
-        <p:spPr>
-          <a:xfrm xmlns:a="http://schemas.openxmlformats.org/drawingml/2006/main">
+        </ns0:spPr>
+      </ns0:sp>
+      <ns0:sp>
+        <ns0:nvSpPr>
+          <ns0:cNvPr id="12" name="">
+            <a:extLst>
+              <a:ext uri="{FF2B5EF4-FFF2-40B4-BE49-F238E27FC236}">
+                <ns2:creationId id="{2A7532DB-EEDB-4682-BFDE-D872D8787FC2}"/>
+              </a:ext>
+            </a:extLst>
+          </ns0:cNvPr>
+          <ns0:cNvSpPr>
+            <a:spLocks noGrp="1"/>
+          </ns0:cNvSpPr>
+          <ns0:nvPr/>
+        </ns0:nvSpPr>
+        <ns0:spPr>
+          <a:xfrm>
             <a:off x="3524250" y="2419350"/>
             <a:ext cx="1990725" cy="171450"/>
           </a:xfrm>
-          <a:prstGeom xmlns:a="http://schemas.openxmlformats.org/drawingml/2006/main" prst="rect">
-            <a:avLst/>
-          </a:prstGeom>
-          <a:solidFill xmlns:a="http://schemas.openxmlformats.org/drawingml/2006/main">
-            <a:srgbClr val="000000">
-              <a:alpha val="0"/>
-            </a:srgbClr>
-          </a:solidFill>
-          <a:ln xmlns:a="http://schemas.openxmlformats.org/drawingml/2006/main" w="0">
-            <a:solidFill>
-              <a:srgbClr val="000000">
-                <a:alpha val="0"/>
-              </a:srgbClr>
-            </a:solidFill>
-            <a:prstDash val="solid"/>
-          </a:ln>
-        </p:spPr>
-        <p:txBody>
-          <a:bodyPr xmlns:a="http://schemas.openxmlformats.org/drawingml/2006/main" lIns="0" tIns="0" rIns="0" bIns="0" anchor="t"/>
-          <a:lstStyle xmlns:a="http://schemas.openxmlformats.org/drawingml/2006/main"/>
-          <a:p xmlns:a="http://schemas.openxmlformats.org/drawingml/2006/main">
+          <a:prstGeom prst="rect">
+            <a:avLst/>
+          </a:prstGeom>
+          <a:solidFill>
+            <a:srgbClr val="000000">
+              <a:alpha val="0"/>
+            </a:srgbClr>
+          </a:solidFill>
+          <a:ln w="0">
+            <a:solidFill>
+              <a:srgbClr val="000000">
+                <a:alpha val="0"/>
+              </a:srgbClr>
+            </a:solidFill>
+            <a:prstDash val="solid"/>
+          </a:ln>
+        </ns0:spPr>
+        <ns0:txBody>
+          <a:bodyPr lIns="0" tIns="0" rIns="0" bIns="0" anchor="t"/>
+          <a:lstStyle/>
+          <a:p>
             <a:pPr algn="l">
               <a:defRPr sz="975" b="1">
                 <a:solidFill>
@@ -7308,51 +7308,51 @@
                 <a:ea typeface="Aptos"/>
                 <a:cs typeface="Aptos"/>
               </a:rPr>
-              <a:t>Riego medio díario</a:t>
-            </a:r>
-          </a:p>
-        </p:txBody>
-      </p:sp>
-      <p:sp>
-        <p:nvSpPr>
-          <p:cNvPr id="13" name="">
-            <a:extLst xmlns:a="http://schemas.openxmlformats.org/drawingml/2006/main">
-              <a:ext uri="{FF2B5EF4-FFF2-40B4-BE49-F238E27FC236}">
-                <a16:creationId xmlns:a16="http://schemas.microsoft.com/office/drawing/2014/main" id="{41A92B73-1758-494D-ACF0-D49D458DB47B}"/>
-              </a:ext>
-            </a:extLst>
-          </p:cNvPr>
-          <p:cNvSpPr>
-            <a:spLocks xmlns:a="http://schemas.openxmlformats.org/drawingml/2006/main" noGrp="1"/>
-          </p:cNvSpPr>
-          <p:nvPr/>
-        </p:nvSpPr>
-        <p:spPr>
-          <a:xfrm xmlns:a="http://schemas.openxmlformats.org/drawingml/2006/main">
+              <a:t>Riego medio diario</a:t>
+            </a:r>
+          </a:p>
+        </ns0:txBody>
+      </ns0:sp>
+      <ns0:sp>
+        <ns0:nvSpPr>
+          <ns0:cNvPr id="13" name="">
+            <a:extLst>
+              <a:ext uri="{FF2B5EF4-FFF2-40B4-BE49-F238E27FC236}">
+                <ns2:creationId id="{41A92B73-1758-494D-ACF0-D49D458DB47B}"/>
+              </a:ext>
+            </a:extLst>
+          </ns0:cNvPr>
+          <ns0:cNvSpPr>
+            <a:spLocks noGrp="1"/>
+          </ns0:cNvSpPr>
+          <ns0:nvPr/>
+        </ns0:nvSpPr>
+        <ns0:spPr>
+          <a:xfrm>
             <a:off x="3524250" y="2647950"/>
             <a:ext cx="1990725" cy="400050"/>
           </a:xfrm>
-          <a:prstGeom xmlns:a="http://schemas.openxmlformats.org/drawingml/2006/main" prst="rect">
-            <a:avLst/>
-          </a:prstGeom>
-          <a:solidFill xmlns:a="http://schemas.openxmlformats.org/drawingml/2006/main">
-            <a:srgbClr val="000000">
-              <a:alpha val="0"/>
-            </a:srgbClr>
-          </a:solidFill>
-          <a:ln xmlns:a="http://schemas.openxmlformats.org/drawingml/2006/main" w="0">
-            <a:solidFill>
-              <a:srgbClr val="000000">
-                <a:alpha val="0"/>
-              </a:srgbClr>
-            </a:solidFill>
-            <a:prstDash val="solid"/>
-          </a:ln>
-        </p:spPr>
-        <p:txBody>
-          <a:bodyPr xmlns:a="http://schemas.openxmlformats.org/drawingml/2006/main" lIns="0" tIns="0" rIns="0" bIns="0" anchor="t"/>
-          <a:lstStyle xmlns:a="http://schemas.openxmlformats.org/drawingml/2006/main"/>
-          <a:p xmlns:a="http://schemas.openxmlformats.org/drawingml/2006/main">
+          <a:prstGeom prst="rect">
+            <a:avLst/>
+          </a:prstGeom>
+          <a:solidFill>
+            <a:srgbClr val="000000">
+              <a:alpha val="0"/>
+            </a:srgbClr>
+          </a:solidFill>
+          <a:ln w="0">
+            <a:solidFill>
+              <a:srgbClr val="000000">
+                <a:alpha val="0"/>
+              </a:srgbClr>
+            </a:solidFill>
+            <a:prstDash val="solid"/>
+          </a:ln>
+        </ns0:spPr>
+        <ns0:txBody>
+          <a:bodyPr lIns="0" tIns="0" rIns="0" bIns="0" anchor="t"/>
+          <a:lstStyle/>
+          <a:p>
             <a:pPr algn="l">
               <a:defRPr sz="1875" b="1">
                 <a:solidFill>
@@ -7375,48 +7375,48 @@
               <a:t>13.879 L/día</a:t>
             </a:r>
           </a:p>
-        </p:txBody>
-      </p:sp>
-      <p:sp>
-        <p:nvSpPr>
-          <p:cNvPr id="14" name="">
-            <a:extLst xmlns:a="http://schemas.openxmlformats.org/drawingml/2006/main">
-              <a:ext uri="{FF2B5EF4-FFF2-40B4-BE49-F238E27FC236}">
-                <a16:creationId xmlns:a16="http://schemas.microsoft.com/office/drawing/2014/main" id="{3BE959BC-A86F-4AB4-BA8C-E5698B765FEA}"/>
-              </a:ext>
-            </a:extLst>
-          </p:cNvPr>
-          <p:cNvSpPr>
-            <a:spLocks xmlns:a="http://schemas.openxmlformats.org/drawingml/2006/main" noGrp="1"/>
-          </p:cNvSpPr>
-          <p:nvPr/>
-        </p:nvSpPr>
-        <p:spPr>
-          <a:xfrm xmlns:a="http://schemas.openxmlformats.org/drawingml/2006/main">
+        </ns0:txBody>
+      </ns0:sp>
+      <ns0:sp>
+        <ns0:nvSpPr>
+          <ns0:cNvPr id="14" name="">
+            <a:extLst>
+              <a:ext uri="{FF2B5EF4-FFF2-40B4-BE49-F238E27FC236}">
+                <ns2:creationId id="{3BE959BC-A86F-4AB4-BA8C-E5698B765FEA}"/>
+              </a:ext>
+            </a:extLst>
+          </ns0:cNvPr>
+          <ns0:cNvSpPr>
+            <a:spLocks noGrp="1"/>
+          </ns0:cNvSpPr>
+          <ns0:nvPr/>
+        </ns0:nvSpPr>
+        <ns0:spPr>
+          <a:xfrm>
             <a:off x="3524250" y="3086100"/>
             <a:ext cx="1990725" cy="266700"/>
           </a:xfrm>
-          <a:prstGeom xmlns:a="http://schemas.openxmlformats.org/drawingml/2006/main" prst="rect">
-            <a:avLst/>
-          </a:prstGeom>
-          <a:solidFill xmlns:a="http://schemas.openxmlformats.org/drawingml/2006/main">
-            <a:srgbClr val="000000">
-              <a:alpha val="0"/>
-            </a:srgbClr>
-          </a:solidFill>
-          <a:ln xmlns:a="http://schemas.openxmlformats.org/drawingml/2006/main" w="0">
-            <a:solidFill>
-              <a:srgbClr val="000000">
-                <a:alpha val="0"/>
-              </a:srgbClr>
-            </a:solidFill>
-            <a:prstDash val="solid"/>
-          </a:ln>
-        </p:spPr>
-        <p:txBody>
-          <a:bodyPr xmlns:a="http://schemas.openxmlformats.org/drawingml/2006/main" lIns="0" tIns="0" rIns="0" bIns="0" anchor="t"/>
-          <a:lstStyle xmlns:a="http://schemas.openxmlformats.org/drawingml/2006/main"/>
-          <a:p xmlns:a="http://schemas.openxmlformats.org/drawingml/2006/main">
+          <a:prstGeom prst="rect">
+            <a:avLst/>
+          </a:prstGeom>
+          <a:solidFill>
+            <a:srgbClr val="000000">
+              <a:alpha val="0"/>
+            </a:srgbClr>
+          </a:solidFill>
+          <a:ln w="0">
+            <a:solidFill>
+              <a:srgbClr val="000000">
+                <a:alpha val="0"/>
+              </a:srgbClr>
+            </a:solidFill>
+            <a:prstDash val="solid"/>
+          </a:ln>
+        </ns0:spPr>
+        <ns0:txBody>
+          <a:bodyPr lIns="0" tIns="0" rIns="0" bIns="0" anchor="t"/>
+          <a:lstStyle/>
+          <a:p>
             <a:pPr algn="l">
               <a:defRPr sz="900" b="0">
                 <a:solidFill>
@@ -7436,84 +7436,84 @@
                 <a:ea typeface="Aptos"/>
                 <a:cs typeface="Aptos"/>
               </a:rPr>
-              <a:t>Promedio díario para toda la parcela.</a:t>
-            </a:r>
-          </a:p>
-        </p:txBody>
-      </p:sp>
-      <p:sp>
-        <p:nvSpPr>
-          <p:cNvPr id="15" name="">
-            <a:extLst xmlns:a="http://schemas.openxmlformats.org/drawingml/2006/main">
-              <a:ext uri="{FF2B5EF4-FFF2-40B4-BE49-F238E27FC236}">
-                <a16:creationId xmlns:a16="http://schemas.microsoft.com/office/drawing/2014/main" id="{91827281-1438-413F-8E6B-D584448F0C28}"/>
-              </a:ext>
-            </a:extLst>
-          </p:cNvPr>
-          <p:cNvSpPr>
-            <a:spLocks xmlns:a="http://schemas.openxmlformats.org/drawingml/2006/main" noGrp="1"/>
-          </p:cNvSpPr>
-          <p:nvPr/>
-        </p:nvSpPr>
-        <p:spPr>
-          <a:xfrm xmlns:a="http://schemas.openxmlformats.org/drawingml/2006/main">
+              <a:t>Promedio diario para toda la parcela.</a:t>
+            </a:r>
+          </a:p>
+        </ns0:txBody>
+      </ns0:sp>
+      <ns0:sp>
+        <ns0:nvSpPr>
+          <ns0:cNvPr id="15" name="">
+            <a:extLst>
+              <a:ext uri="{FF2B5EF4-FFF2-40B4-BE49-F238E27FC236}">
+                <ns2:creationId id="{91827281-1438-413F-8E6B-D584448F0C28}"/>
+              </a:ext>
+            </a:extLst>
+          </ns0:cNvPr>
+          <ns0:cNvSpPr>
+            <a:spLocks noGrp="1"/>
+          </ns0:cNvSpPr>
+          <ns0:nvPr/>
+        </ns0:nvSpPr>
+        <ns0:spPr>
+          <a:xfrm>
             <a:off x="6019800" y="2266950"/>
             <a:ext cx="2333625" cy="1104900"/>
           </a:xfrm>
-          <a:prstGeom xmlns:a="http://schemas.openxmlformats.org/drawingml/2006/main" prst="rect">
-            <a:avLst/>
-          </a:prstGeom>
-          <a:solidFill xmlns:a="http://schemas.openxmlformats.org/drawingml/2006/main">
+          <a:prstGeom prst="rect">
+            <a:avLst/>
+          </a:prstGeom>
+          <a:solidFill>
             <a:srgbClr val="FFFFFF"/>
           </a:solidFill>
-          <a:ln xmlns:a="http://schemas.openxmlformats.org/drawingml/2006/main" w="9525">
+          <a:ln w="9525">
             <a:solidFill>
               <a:srgbClr val="CBD5C7"/>
             </a:solidFill>
             <a:prstDash val="solid"/>
           </a:ln>
-        </p:spPr>
-      </p:sp>
-      <p:sp>
-        <p:nvSpPr>
-          <p:cNvPr id="16" name="">
-            <a:extLst xmlns:a="http://schemas.openxmlformats.org/drawingml/2006/main">
-              <a:ext uri="{FF2B5EF4-FFF2-40B4-BE49-F238E27FC236}">
-                <a16:creationId xmlns:a16="http://schemas.microsoft.com/office/drawing/2014/main" id="{CC755839-40F2-47FE-A1DF-5D03903DFB46}"/>
-              </a:ext>
-            </a:extLst>
-          </p:cNvPr>
-          <p:cNvSpPr>
-            <a:spLocks xmlns:a="http://schemas.openxmlformats.org/drawingml/2006/main" noGrp="1"/>
-          </p:cNvSpPr>
-          <p:nvPr/>
-        </p:nvSpPr>
-        <p:spPr>
-          <a:xfrm xmlns:a="http://schemas.openxmlformats.org/drawingml/2006/main">
+        </ns0:spPr>
+      </ns0:sp>
+      <ns0:sp>
+        <ns0:nvSpPr>
+          <ns0:cNvPr id="16" name="">
+            <a:extLst>
+              <a:ext uri="{FF2B5EF4-FFF2-40B4-BE49-F238E27FC236}">
+                <ns2:creationId id="{CC755839-40F2-47FE-A1DF-5D03903DFB46}"/>
+              </a:ext>
+            </a:extLst>
+          </ns0:cNvPr>
+          <ns0:cNvSpPr>
+            <a:spLocks noGrp="1"/>
+          </ns0:cNvSpPr>
+          <ns0:nvPr/>
+        </ns0:nvSpPr>
+        <ns0:spPr>
+          <a:xfrm>
             <a:off x="6191250" y="2419350"/>
             <a:ext cx="1990725" cy="171450"/>
           </a:xfrm>
-          <a:prstGeom xmlns:a="http://schemas.openxmlformats.org/drawingml/2006/main" prst="rect">
-            <a:avLst/>
-          </a:prstGeom>
-          <a:solidFill xmlns:a="http://schemas.openxmlformats.org/drawingml/2006/main">
-            <a:srgbClr val="000000">
-              <a:alpha val="0"/>
-            </a:srgbClr>
-          </a:solidFill>
-          <a:ln xmlns:a="http://schemas.openxmlformats.org/drawingml/2006/main" w="0">
-            <a:solidFill>
-              <a:srgbClr val="000000">
-                <a:alpha val="0"/>
-              </a:srgbClr>
-            </a:solidFill>
-            <a:prstDash val="solid"/>
-          </a:ln>
-        </p:spPr>
-        <p:txBody>
-          <a:bodyPr xmlns:a="http://schemas.openxmlformats.org/drawingml/2006/main" lIns="0" tIns="0" rIns="0" bIns="0" anchor="t"/>
-          <a:lstStyle xmlns:a="http://schemas.openxmlformats.org/drawingml/2006/main"/>
-          <a:p xmlns:a="http://schemas.openxmlformats.org/drawingml/2006/main">
+          <a:prstGeom prst="rect">
+            <a:avLst/>
+          </a:prstGeom>
+          <a:solidFill>
+            <a:srgbClr val="000000">
+              <a:alpha val="0"/>
+            </a:srgbClr>
+          </a:solidFill>
+          <a:ln w="0">
+            <a:solidFill>
+              <a:srgbClr val="000000">
+                <a:alpha val="0"/>
+              </a:srgbClr>
+            </a:solidFill>
+            <a:prstDash val="solid"/>
+          </a:ln>
+        </ns0:spPr>
+        <ns0:txBody>
+          <a:bodyPr lIns="0" tIns="0" rIns="0" bIns="0" anchor="t"/>
+          <a:lstStyle/>
+          <a:p>
             <a:pPr algn="l">
               <a:defRPr sz="975" b="1">
                 <a:solidFill>
@@ -7536,48 +7536,48 @@
               <a:t>Litros por planta</a:t>
             </a:r>
           </a:p>
-        </p:txBody>
-      </p:sp>
-      <p:sp>
-        <p:nvSpPr>
-          <p:cNvPr id="17" name="">
-            <a:extLst xmlns:a="http://schemas.openxmlformats.org/drawingml/2006/main">
-              <a:ext uri="{FF2B5EF4-FFF2-40B4-BE49-F238E27FC236}">
-                <a16:creationId xmlns:a16="http://schemas.microsoft.com/office/drawing/2014/main" id="{36BFE408-DDAA-4AF4-A74F-99417C6C1735}"/>
-              </a:ext>
-            </a:extLst>
-          </p:cNvPr>
-          <p:cNvSpPr>
-            <a:spLocks xmlns:a="http://schemas.openxmlformats.org/drawingml/2006/main" noGrp="1"/>
-          </p:cNvSpPr>
-          <p:nvPr/>
-        </p:nvSpPr>
-        <p:spPr>
-          <a:xfrm xmlns:a="http://schemas.openxmlformats.org/drawingml/2006/main">
+        </ns0:txBody>
+      </ns0:sp>
+      <ns0:sp>
+        <ns0:nvSpPr>
+          <ns0:cNvPr id="17" name="">
+            <a:extLst>
+              <a:ext uri="{FF2B5EF4-FFF2-40B4-BE49-F238E27FC236}">
+                <ns2:creationId id="{36BFE408-DDAA-4AF4-A74F-99417C6C1735}"/>
+              </a:ext>
+            </a:extLst>
+          </ns0:cNvPr>
+          <ns0:cNvSpPr>
+            <a:spLocks noGrp="1"/>
+          </ns0:cNvSpPr>
+          <ns0:nvPr/>
+        </ns0:nvSpPr>
+        <ns0:spPr>
+          <a:xfrm>
             <a:off x="6191250" y="2647950"/>
             <a:ext cx="1990725" cy="400050"/>
           </a:xfrm>
-          <a:prstGeom xmlns:a="http://schemas.openxmlformats.org/drawingml/2006/main" prst="rect">
-            <a:avLst/>
-          </a:prstGeom>
-          <a:solidFill xmlns:a="http://schemas.openxmlformats.org/drawingml/2006/main">
-            <a:srgbClr val="000000">
-              <a:alpha val="0"/>
-            </a:srgbClr>
-          </a:solidFill>
-          <a:ln xmlns:a="http://schemas.openxmlformats.org/drawingml/2006/main" w="0">
-            <a:solidFill>
-              <a:srgbClr val="000000">
-                <a:alpha val="0"/>
-              </a:srgbClr>
-            </a:solidFill>
-            <a:prstDash val="solid"/>
-          </a:ln>
-        </p:spPr>
-        <p:txBody>
-          <a:bodyPr xmlns:a="http://schemas.openxmlformats.org/drawingml/2006/main" lIns="0" tIns="0" rIns="0" bIns="0" anchor="t"/>
-          <a:lstStyle xmlns:a="http://schemas.openxmlformats.org/drawingml/2006/main"/>
-          <a:p xmlns:a="http://schemas.openxmlformats.org/drawingml/2006/main">
+          <a:prstGeom prst="rect">
+            <a:avLst/>
+          </a:prstGeom>
+          <a:solidFill>
+            <a:srgbClr val="000000">
+              <a:alpha val="0"/>
+            </a:srgbClr>
+          </a:solidFill>
+          <a:ln w="0">
+            <a:solidFill>
+              <a:srgbClr val="000000">
+                <a:alpha val="0"/>
+              </a:srgbClr>
+            </a:solidFill>
+            <a:prstDash val="solid"/>
+          </a:ln>
+        </ns0:spPr>
+        <ns0:txBody>
+          <a:bodyPr lIns="0" tIns="0" rIns="0" bIns="0" anchor="t"/>
+          <a:lstStyle/>
+          <a:p>
             <a:pPr algn="l">
               <a:defRPr sz="1500" b="1">
                 <a:solidFill>
@@ -7600,48 +7600,48 @@
               <a:t>31,72 L/planta/día</a:t>
             </a:r>
           </a:p>
-        </p:txBody>
-      </p:sp>
-      <p:sp>
-        <p:nvSpPr>
-          <p:cNvPr id="18" name="">
-            <a:extLst xmlns:a="http://schemas.openxmlformats.org/drawingml/2006/main">
-              <a:ext uri="{FF2B5EF4-FFF2-40B4-BE49-F238E27FC236}">
-                <a16:creationId xmlns:a16="http://schemas.microsoft.com/office/drawing/2014/main" id="{4818A6BE-77C8-47AA-BAB5-280201479288}"/>
-              </a:ext>
-            </a:extLst>
-          </p:cNvPr>
-          <p:cNvSpPr>
-            <a:spLocks xmlns:a="http://schemas.openxmlformats.org/drawingml/2006/main" noGrp="1"/>
-          </p:cNvSpPr>
-          <p:nvPr/>
-        </p:nvSpPr>
-        <p:spPr>
-          <a:xfrm xmlns:a="http://schemas.openxmlformats.org/drawingml/2006/main">
+        </ns0:txBody>
+      </ns0:sp>
+      <ns0:sp>
+        <ns0:nvSpPr>
+          <ns0:cNvPr id="18" name="">
+            <a:extLst>
+              <a:ext uri="{FF2B5EF4-FFF2-40B4-BE49-F238E27FC236}">
+                <ns2:creationId id="{4818A6BE-77C8-47AA-BAB5-280201479288}"/>
+              </a:ext>
+            </a:extLst>
+          </ns0:cNvPr>
+          <ns0:cNvSpPr>
+            <a:spLocks noGrp="1"/>
+          </ns0:cNvSpPr>
+          <ns0:nvPr/>
+        </ns0:nvSpPr>
+        <ns0:spPr>
+          <a:xfrm>
             <a:off x="6191250" y="3086100"/>
             <a:ext cx="1990725" cy="266700"/>
           </a:xfrm>
-          <a:prstGeom xmlns:a="http://schemas.openxmlformats.org/drawingml/2006/main" prst="rect">
-            <a:avLst/>
-          </a:prstGeom>
-          <a:solidFill xmlns:a="http://schemas.openxmlformats.org/drawingml/2006/main">
-            <a:srgbClr val="000000">
-              <a:alpha val="0"/>
-            </a:srgbClr>
-          </a:solidFill>
-          <a:ln xmlns:a="http://schemas.openxmlformats.org/drawingml/2006/main" w="0">
-            <a:solidFill>
-              <a:srgbClr val="000000">
-                <a:alpha val="0"/>
-              </a:srgbClr>
-            </a:solidFill>
-            <a:prstDash val="solid"/>
-          </a:ln>
-        </p:spPr>
-        <p:txBody>
-          <a:bodyPr xmlns:a="http://schemas.openxmlformats.org/drawingml/2006/main" lIns="0" tIns="0" rIns="0" bIns="0" anchor="t"/>
-          <a:lstStyle xmlns:a="http://schemas.openxmlformats.org/drawingml/2006/main"/>
-          <a:p xmlns:a="http://schemas.openxmlformats.org/drawingml/2006/main">
+          <a:prstGeom prst="rect">
+            <a:avLst/>
+          </a:prstGeom>
+          <a:solidFill>
+            <a:srgbClr val="000000">
+              <a:alpha val="0"/>
+            </a:srgbClr>
+          </a:solidFill>
+          <a:ln w="0">
+            <a:solidFill>
+              <a:srgbClr val="000000">
+                <a:alpha val="0"/>
+              </a:srgbClr>
+            </a:solidFill>
+            <a:prstDash val="solid"/>
+          </a:ln>
+        </ns0:spPr>
+        <ns0:txBody>
+          <a:bodyPr lIns="0" tIns="0" rIns="0" bIns="0" anchor="t"/>
+          <a:lstStyle/>
+          <a:p>
             <a:pPr algn="l">
               <a:defRPr sz="900" b="0">
                 <a:solidFill>
@@ -7661,84 +7661,84 @@
                 <a:ea typeface="Aptos"/>
                 <a:cs typeface="Aptos"/>
               </a:rPr>
-              <a:t>Media díaria estimada por planta.</a:t>
-            </a:r>
-          </a:p>
-        </p:txBody>
-      </p:sp>
-      <p:sp>
-        <p:nvSpPr>
-          <p:cNvPr id="19" name="">
-            <a:extLst xmlns:a="http://schemas.openxmlformats.org/drawingml/2006/main">
-              <a:ext uri="{FF2B5EF4-FFF2-40B4-BE49-F238E27FC236}">
-                <a16:creationId xmlns:a16="http://schemas.microsoft.com/office/drawing/2014/main" id="{60A3867B-5509-439A-9272-69EBDA1F785A}"/>
-              </a:ext>
-            </a:extLst>
-          </p:cNvPr>
-          <p:cNvSpPr>
-            <a:spLocks xmlns:a="http://schemas.openxmlformats.org/drawingml/2006/main" noGrp="1"/>
-          </p:cNvSpPr>
-          <p:nvPr/>
-        </p:nvSpPr>
-        <p:spPr>
-          <a:xfrm xmlns:a="http://schemas.openxmlformats.org/drawingml/2006/main">
+              <a:t>Media diaria estimada por planta.</a:t>
+            </a:r>
+          </a:p>
+        </ns0:txBody>
+      </ns0:sp>
+      <ns0:sp>
+        <ns0:nvSpPr>
+          <ns0:cNvPr id="19" name="">
+            <a:extLst>
+              <a:ext uri="{FF2B5EF4-FFF2-40B4-BE49-F238E27FC236}">
+                <ns2:creationId id="{60A3867B-5509-439A-9272-69EBDA1F785A}"/>
+              </a:ext>
+            </a:extLst>
+          </ns0:cNvPr>
+          <ns0:cNvSpPr>
+            <a:spLocks noGrp="1"/>
+          </ns0:cNvSpPr>
+          <ns0:nvPr/>
+        </ns0:nvSpPr>
+        <ns0:spPr>
+          <a:xfrm>
             <a:off x="8686800" y="2266950"/>
             <a:ext cx="2333625" cy="1104900"/>
           </a:xfrm>
-          <a:prstGeom xmlns:a="http://schemas.openxmlformats.org/drawingml/2006/main" prst="rect">
-            <a:avLst/>
-          </a:prstGeom>
-          <a:solidFill xmlns:a="http://schemas.openxmlformats.org/drawingml/2006/main">
+          <a:prstGeom prst="rect">
+            <a:avLst/>
+          </a:prstGeom>
+          <a:solidFill>
             <a:srgbClr val="FFFFFF"/>
           </a:solidFill>
-          <a:ln xmlns:a="http://schemas.openxmlformats.org/drawingml/2006/main" w="9525">
+          <a:ln w="9525">
             <a:solidFill>
               <a:srgbClr val="CBD5C7"/>
             </a:solidFill>
             <a:prstDash val="solid"/>
           </a:ln>
-        </p:spPr>
-      </p:sp>
-      <p:sp>
-        <p:nvSpPr>
-          <p:cNvPr id="20" name="">
-            <a:extLst xmlns:a="http://schemas.openxmlformats.org/drawingml/2006/main">
-              <a:ext uri="{FF2B5EF4-FFF2-40B4-BE49-F238E27FC236}">
-                <a16:creationId xmlns:a16="http://schemas.microsoft.com/office/drawing/2014/main" id="{BBF62C6D-3090-4664-8A7B-1BF8EAE8FA22}"/>
-              </a:ext>
-            </a:extLst>
-          </p:cNvPr>
-          <p:cNvSpPr>
-            <a:spLocks xmlns:a="http://schemas.openxmlformats.org/drawingml/2006/main" noGrp="1"/>
-          </p:cNvSpPr>
-          <p:nvPr/>
-        </p:nvSpPr>
-        <p:spPr>
-          <a:xfrm xmlns:a="http://schemas.openxmlformats.org/drawingml/2006/main">
+        </ns0:spPr>
+      </ns0:sp>
+      <ns0:sp>
+        <ns0:nvSpPr>
+          <ns0:cNvPr id="20" name="">
+            <a:extLst>
+              <a:ext uri="{FF2B5EF4-FFF2-40B4-BE49-F238E27FC236}">
+                <ns2:creationId id="{BBF62C6D-3090-4664-8A7B-1BF8EAE8FA22}"/>
+              </a:ext>
+            </a:extLst>
+          </ns0:cNvPr>
+          <ns0:cNvSpPr>
+            <a:spLocks noGrp="1"/>
+          </ns0:cNvSpPr>
+          <ns0:nvPr/>
+        </ns0:nvSpPr>
+        <ns0:spPr>
+          <a:xfrm>
             <a:off x="8858250" y="2419350"/>
             <a:ext cx="1990725" cy="171450"/>
           </a:xfrm>
-          <a:prstGeom xmlns:a="http://schemas.openxmlformats.org/drawingml/2006/main" prst="rect">
-            <a:avLst/>
-          </a:prstGeom>
-          <a:solidFill xmlns:a="http://schemas.openxmlformats.org/drawingml/2006/main">
-            <a:srgbClr val="000000">
-              <a:alpha val="0"/>
-            </a:srgbClr>
-          </a:solidFill>
-          <a:ln xmlns:a="http://schemas.openxmlformats.org/drawingml/2006/main" w="0">
-            <a:solidFill>
-              <a:srgbClr val="000000">
-                <a:alpha val="0"/>
-              </a:srgbClr>
-            </a:solidFill>
-            <a:prstDash val="solid"/>
-          </a:ln>
-        </p:spPr>
-        <p:txBody>
-          <a:bodyPr xmlns:a="http://schemas.openxmlformats.org/drawingml/2006/main" lIns="0" tIns="0" rIns="0" bIns="0" anchor="t"/>
-          <a:lstStyle xmlns:a="http://schemas.openxmlformats.org/drawingml/2006/main"/>
-          <a:p xmlns:a="http://schemas.openxmlformats.org/drawingml/2006/main">
+          <a:prstGeom prst="rect">
+            <a:avLst/>
+          </a:prstGeom>
+          <a:solidFill>
+            <a:srgbClr val="000000">
+              <a:alpha val="0"/>
+            </a:srgbClr>
+          </a:solidFill>
+          <a:ln w="0">
+            <a:solidFill>
+              <a:srgbClr val="000000">
+                <a:alpha val="0"/>
+              </a:srgbClr>
+            </a:solidFill>
+            <a:prstDash val="solid"/>
+          </a:ln>
+        </ns0:spPr>
+        <ns0:txBody>
+          <a:bodyPr lIns="0" tIns="0" rIns="0" bIns="0" anchor="t"/>
+          <a:lstStyle/>
+          <a:p>
             <a:pPr algn="l">
               <a:defRPr sz="975" b="1">
                 <a:solidFill>
@@ -7758,51 +7758,51 @@
                 <a:ea typeface="Aptos"/>
                 <a:cs typeface="Aptos"/>
               </a:rPr>
-              <a:t>Lámina díaria</a:t>
-            </a:r>
-          </a:p>
-        </p:txBody>
-      </p:sp>
-      <p:sp>
-        <p:nvSpPr>
-          <p:cNvPr id="21" name="">
-            <a:extLst xmlns:a="http://schemas.openxmlformats.org/drawingml/2006/main">
-              <a:ext uri="{FF2B5EF4-FFF2-40B4-BE49-F238E27FC236}">
-                <a16:creationId xmlns:a16="http://schemas.microsoft.com/office/drawing/2014/main" id="{7A04C442-71DC-472D-9C38-B90D9BA6086E}"/>
-              </a:ext>
-            </a:extLst>
-          </p:cNvPr>
-          <p:cNvSpPr>
-            <a:spLocks xmlns:a="http://schemas.openxmlformats.org/drawingml/2006/main" noGrp="1"/>
-          </p:cNvSpPr>
-          <p:nvPr/>
-        </p:nvSpPr>
-        <p:spPr>
-          <a:xfrm xmlns:a="http://schemas.openxmlformats.org/drawingml/2006/main">
+              <a:t>Lámina diaria</a:t>
+            </a:r>
+          </a:p>
+        </ns0:txBody>
+      </ns0:sp>
+      <ns0:sp>
+        <ns0:nvSpPr>
+          <ns0:cNvPr id="21" name="">
+            <a:extLst>
+              <a:ext uri="{FF2B5EF4-FFF2-40B4-BE49-F238E27FC236}">
+                <ns2:creationId id="{7A04C442-71DC-472D-9C38-B90D9BA6086E}"/>
+              </a:ext>
+            </a:extLst>
+          </ns0:cNvPr>
+          <ns0:cNvSpPr>
+            <a:spLocks noGrp="1"/>
+          </ns0:cNvSpPr>
+          <ns0:nvPr/>
+        </ns0:nvSpPr>
+        <ns0:spPr>
+          <a:xfrm>
             <a:off x="8858250" y="2647950"/>
             <a:ext cx="1990725" cy="400050"/>
           </a:xfrm>
-          <a:prstGeom xmlns:a="http://schemas.openxmlformats.org/drawingml/2006/main" prst="rect">
-            <a:avLst/>
-          </a:prstGeom>
-          <a:solidFill xmlns:a="http://schemas.openxmlformats.org/drawingml/2006/main">
-            <a:srgbClr val="000000">
-              <a:alpha val="0"/>
-            </a:srgbClr>
-          </a:solidFill>
-          <a:ln xmlns:a="http://schemas.openxmlformats.org/drawingml/2006/main" w="0">
-            <a:solidFill>
-              <a:srgbClr val="000000">
-                <a:alpha val="0"/>
-              </a:srgbClr>
-            </a:solidFill>
-            <a:prstDash val="solid"/>
-          </a:ln>
-        </p:spPr>
-        <p:txBody>
-          <a:bodyPr xmlns:a="http://schemas.openxmlformats.org/drawingml/2006/main" lIns="0" tIns="0" rIns="0" bIns="0" anchor="t"/>
-          <a:lstStyle xmlns:a="http://schemas.openxmlformats.org/drawingml/2006/main"/>
-          <a:p xmlns:a="http://schemas.openxmlformats.org/drawingml/2006/main">
+          <a:prstGeom prst="rect">
+            <a:avLst/>
+          </a:prstGeom>
+          <a:solidFill>
+            <a:srgbClr val="000000">
+              <a:alpha val="0"/>
+            </a:srgbClr>
+          </a:solidFill>
+          <a:ln w="0">
+            <a:solidFill>
+              <a:srgbClr val="000000">
+                <a:alpha val="0"/>
+              </a:srgbClr>
+            </a:solidFill>
+            <a:prstDash val="solid"/>
+          </a:ln>
+        </ns0:spPr>
+        <ns0:txBody>
+          <a:bodyPr lIns="0" tIns="0" rIns="0" bIns="0" anchor="t"/>
+          <a:lstStyle/>
+          <a:p>
             <a:pPr algn="l">
               <a:defRPr sz="1875" b="1">
                 <a:solidFill>
@@ -7825,48 +7825,48 @@
               <a:t>3,97 mm/día</a:t>
             </a:r>
           </a:p>
-        </p:txBody>
-      </p:sp>
-      <p:sp>
-        <p:nvSpPr>
-          <p:cNvPr id="22" name="">
-            <a:extLst xmlns:a="http://schemas.openxmlformats.org/drawingml/2006/main">
-              <a:ext uri="{FF2B5EF4-FFF2-40B4-BE49-F238E27FC236}">
-                <a16:creationId xmlns:a16="http://schemas.microsoft.com/office/drawing/2014/main" id="{2CA6107D-EBA8-410F-90EB-A92A3DAE9149}"/>
-              </a:ext>
-            </a:extLst>
-          </p:cNvPr>
-          <p:cNvSpPr>
-            <a:spLocks xmlns:a="http://schemas.openxmlformats.org/drawingml/2006/main" noGrp="1"/>
-          </p:cNvSpPr>
-          <p:nvPr/>
-        </p:nvSpPr>
-        <p:spPr>
-          <a:xfrm xmlns:a="http://schemas.openxmlformats.org/drawingml/2006/main">
+        </ns0:txBody>
+      </ns0:sp>
+      <ns0:sp>
+        <ns0:nvSpPr>
+          <ns0:cNvPr id="22" name="">
+            <a:extLst>
+              <a:ext uri="{FF2B5EF4-FFF2-40B4-BE49-F238E27FC236}">
+                <ns2:creationId id="{2CA6107D-EBA8-410F-90EB-A92A3DAE9149}"/>
+              </a:ext>
+            </a:extLst>
+          </ns0:cNvPr>
+          <ns0:cNvSpPr>
+            <a:spLocks noGrp="1"/>
+          </ns0:cNvSpPr>
+          <ns0:nvPr/>
+        </ns0:nvSpPr>
+        <ns0:spPr>
+          <a:xfrm>
             <a:off x="8858250" y="3086100"/>
             <a:ext cx="1990725" cy="266700"/>
           </a:xfrm>
-          <a:prstGeom xmlns:a="http://schemas.openxmlformats.org/drawingml/2006/main" prst="rect">
-            <a:avLst/>
-          </a:prstGeom>
-          <a:solidFill xmlns:a="http://schemas.openxmlformats.org/drawingml/2006/main">
-            <a:srgbClr val="000000">
-              <a:alpha val="0"/>
-            </a:srgbClr>
-          </a:solidFill>
-          <a:ln xmlns:a="http://schemas.openxmlformats.org/drawingml/2006/main" w="0">
-            <a:solidFill>
-              <a:srgbClr val="000000">
-                <a:alpha val="0"/>
-              </a:srgbClr>
-            </a:solidFill>
-            <a:prstDash val="solid"/>
-          </a:ln>
-        </p:spPr>
-        <p:txBody>
-          <a:bodyPr xmlns:a="http://schemas.openxmlformats.org/drawingml/2006/main" lIns="0" tIns="0" rIns="0" bIns="0" anchor="t"/>
-          <a:lstStyle xmlns:a="http://schemas.openxmlformats.org/drawingml/2006/main"/>
-          <a:p xmlns:a="http://schemas.openxmlformats.org/drawingml/2006/main">
+          <a:prstGeom prst="rect">
+            <a:avLst/>
+          </a:prstGeom>
+          <a:solidFill>
+            <a:srgbClr val="000000">
+              <a:alpha val="0"/>
+            </a:srgbClr>
+          </a:solidFill>
+          <a:ln w="0">
+            <a:solidFill>
+              <a:srgbClr val="000000">
+                <a:alpha val="0"/>
+              </a:srgbClr>
+            </a:solidFill>
+            <a:prstDash val="solid"/>
+          </a:ln>
+        </ns0:spPr>
+        <ns0:txBody>
+          <a:bodyPr lIns="0" tIns="0" rIns="0" bIns="0" anchor="t"/>
+          <a:lstStyle/>
+          <a:p>
             <a:pPr algn="l">
               <a:defRPr sz="900" b="0">
                 <a:solidFill>
@@ -7889,81 +7889,81 @@
               <a:t>Profundidad media aplicada al terreno.</a:t>
             </a:r>
           </a:p>
-        </p:txBody>
-      </p:sp>
-      <p:sp>
-        <p:nvSpPr>
-          <p:cNvPr id="23" name="">
-            <a:extLst xmlns:a="http://schemas.openxmlformats.org/drawingml/2006/main">
-              <a:ext uri="{FF2B5EF4-FFF2-40B4-BE49-F238E27FC236}">
-                <a16:creationId xmlns:a16="http://schemas.microsoft.com/office/drawing/2014/main" id="{039BC57F-ADF2-42A3-AC26-FAAEC0EACA62}"/>
-              </a:ext>
-            </a:extLst>
-          </p:cNvPr>
-          <p:cNvSpPr>
-            <a:spLocks xmlns:a="http://schemas.openxmlformats.org/drawingml/2006/main" noGrp="1"/>
-          </p:cNvSpPr>
-          <p:nvPr/>
-        </p:nvSpPr>
-        <p:spPr>
-          <a:xfrm xmlns:a="http://schemas.openxmlformats.org/drawingml/2006/main">
+        </ns0:txBody>
+      </ns0:sp>
+      <ns0:sp>
+        <ns0:nvSpPr>
+          <ns0:cNvPr id="23" name="">
+            <a:extLst>
+              <a:ext uri="{FF2B5EF4-FFF2-40B4-BE49-F238E27FC236}">
+                <ns2:creationId id="{039BC57F-ADF2-42A3-AC26-FAAEC0EACA62}"/>
+              </a:ext>
+            </a:extLst>
+          </ns0:cNvPr>
+          <ns0:cNvSpPr>
+            <a:spLocks noGrp="1"/>
+          </ns0:cNvSpPr>
+          <ns0:nvPr/>
+        </ns0:nvSpPr>
+        <ns0:spPr>
+          <a:xfrm>
             <a:off x="685800" y="3648075"/>
             <a:ext cx="2333625" cy="1104900"/>
           </a:xfrm>
-          <a:prstGeom xmlns:a="http://schemas.openxmlformats.org/drawingml/2006/main" prst="rect">
-            <a:avLst/>
-          </a:prstGeom>
-          <a:solidFill xmlns:a="http://schemas.openxmlformats.org/drawingml/2006/main">
+          <a:prstGeom prst="rect">
+            <a:avLst/>
+          </a:prstGeom>
+          <a:solidFill>
             <a:srgbClr val="FFFFFF"/>
           </a:solidFill>
-          <a:ln xmlns:a="http://schemas.openxmlformats.org/drawingml/2006/main" w="9525">
+          <a:ln w="9525">
             <a:solidFill>
               <a:srgbClr val="CBD5C7"/>
             </a:solidFill>
             <a:prstDash val="solid"/>
           </a:ln>
-        </p:spPr>
-      </p:sp>
-      <p:sp>
-        <p:nvSpPr>
-          <p:cNvPr id="24" name="">
-            <a:extLst xmlns:a="http://schemas.openxmlformats.org/drawingml/2006/main">
-              <a:ext uri="{FF2B5EF4-FFF2-40B4-BE49-F238E27FC236}">
-                <a16:creationId xmlns:a16="http://schemas.microsoft.com/office/drawing/2014/main" id="{D59F60B4-8268-4DF7-87C4-E9970F968675}"/>
-              </a:ext>
-            </a:extLst>
-          </p:cNvPr>
-          <p:cNvSpPr>
-            <a:spLocks xmlns:a="http://schemas.openxmlformats.org/drawingml/2006/main" noGrp="1"/>
-          </p:cNvSpPr>
-          <p:nvPr/>
-        </p:nvSpPr>
-        <p:spPr>
-          <a:xfrm xmlns:a="http://schemas.openxmlformats.org/drawingml/2006/main">
+        </ns0:spPr>
+      </ns0:sp>
+      <ns0:sp>
+        <ns0:nvSpPr>
+          <ns0:cNvPr id="24" name="">
+            <a:extLst>
+              <a:ext uri="{FF2B5EF4-FFF2-40B4-BE49-F238E27FC236}">
+                <ns2:creationId id="{D59F60B4-8268-4DF7-87C4-E9970F968675}"/>
+              </a:ext>
+            </a:extLst>
+          </ns0:cNvPr>
+          <ns0:cNvSpPr>
+            <a:spLocks noGrp="1"/>
+          </ns0:cNvSpPr>
+          <ns0:nvPr/>
+        </ns0:nvSpPr>
+        <ns0:spPr>
+          <a:xfrm>
             <a:off x="857250" y="3800475"/>
             <a:ext cx="1990725" cy="171450"/>
           </a:xfrm>
-          <a:prstGeom xmlns:a="http://schemas.openxmlformats.org/drawingml/2006/main" prst="rect">
-            <a:avLst/>
-          </a:prstGeom>
-          <a:solidFill xmlns:a="http://schemas.openxmlformats.org/drawingml/2006/main">
-            <a:srgbClr val="000000">
-              <a:alpha val="0"/>
-            </a:srgbClr>
-          </a:solidFill>
-          <a:ln xmlns:a="http://schemas.openxmlformats.org/drawingml/2006/main" w="0">
-            <a:solidFill>
-              <a:srgbClr val="000000">
-                <a:alpha val="0"/>
-              </a:srgbClr>
-            </a:solidFill>
-            <a:prstDash val="solid"/>
-          </a:ln>
-        </p:spPr>
-        <p:txBody>
-          <a:bodyPr xmlns:a="http://schemas.openxmlformats.org/drawingml/2006/main" lIns="0" tIns="0" rIns="0" bIns="0" anchor="t"/>
-          <a:lstStyle xmlns:a="http://schemas.openxmlformats.org/drawingml/2006/main"/>
-          <a:p xmlns:a="http://schemas.openxmlformats.org/drawingml/2006/main">
+          <a:prstGeom prst="rect">
+            <a:avLst/>
+          </a:prstGeom>
+          <a:solidFill>
+            <a:srgbClr val="000000">
+              <a:alpha val="0"/>
+            </a:srgbClr>
+          </a:solidFill>
+          <a:ln w="0">
+            <a:solidFill>
+              <a:srgbClr val="000000">
+                <a:alpha val="0"/>
+              </a:srgbClr>
+            </a:solidFill>
+            <a:prstDash val="solid"/>
+          </a:ln>
+        </ns0:spPr>
+        <ns0:txBody>
+          <a:bodyPr lIns="0" tIns="0" rIns="0" bIns="0" anchor="t"/>
+          <a:lstStyle/>
+          <a:p>
             <a:pPr algn="l">
               <a:defRPr sz="975" b="1">
                 <a:solidFill>
@@ -7986,48 +7986,48 @@
               <a:t>ET0 media</a:t>
             </a:r>
           </a:p>
-        </p:txBody>
-      </p:sp>
-      <p:sp>
-        <p:nvSpPr>
-          <p:cNvPr id="25" name="">
-            <a:extLst xmlns:a="http://schemas.openxmlformats.org/drawingml/2006/main">
-              <a:ext uri="{FF2B5EF4-FFF2-40B4-BE49-F238E27FC236}">
-                <a16:creationId xmlns:a16="http://schemas.microsoft.com/office/drawing/2014/main" id="{A5C4141E-7D17-45E3-A047-4B67B1FEF1BD}"/>
-              </a:ext>
-            </a:extLst>
-          </p:cNvPr>
-          <p:cNvSpPr>
-            <a:spLocks xmlns:a="http://schemas.openxmlformats.org/drawingml/2006/main" noGrp="1"/>
-          </p:cNvSpPr>
-          <p:nvPr/>
-        </p:nvSpPr>
-        <p:spPr>
-          <a:xfrm xmlns:a="http://schemas.openxmlformats.org/drawingml/2006/main">
+        </ns0:txBody>
+      </ns0:sp>
+      <ns0:sp>
+        <ns0:nvSpPr>
+          <ns0:cNvPr id="25" name="">
+            <a:extLst>
+              <a:ext uri="{FF2B5EF4-FFF2-40B4-BE49-F238E27FC236}">
+                <ns2:creationId id="{A5C4141E-7D17-45E3-A047-4B67B1FEF1BD}"/>
+              </a:ext>
+            </a:extLst>
+          </ns0:cNvPr>
+          <ns0:cNvSpPr>
+            <a:spLocks noGrp="1"/>
+          </ns0:cNvSpPr>
+          <ns0:nvPr/>
+        </ns0:nvSpPr>
+        <ns0:spPr>
+          <a:xfrm>
             <a:off x="857250" y="4029075"/>
             <a:ext cx="1990725" cy="400050"/>
           </a:xfrm>
-          <a:prstGeom xmlns:a="http://schemas.openxmlformats.org/drawingml/2006/main" prst="rect">
-            <a:avLst/>
-          </a:prstGeom>
-          <a:solidFill xmlns:a="http://schemas.openxmlformats.org/drawingml/2006/main">
-            <a:srgbClr val="000000">
-              <a:alpha val="0"/>
-            </a:srgbClr>
-          </a:solidFill>
-          <a:ln xmlns:a="http://schemas.openxmlformats.org/drawingml/2006/main" w="0">
-            <a:solidFill>
-              <a:srgbClr val="000000">
-                <a:alpha val="0"/>
-              </a:srgbClr>
-            </a:solidFill>
-            <a:prstDash val="solid"/>
-          </a:ln>
-        </p:spPr>
-        <p:txBody>
-          <a:bodyPr xmlns:a="http://schemas.openxmlformats.org/drawingml/2006/main" lIns="0" tIns="0" rIns="0" bIns="0" anchor="t"/>
-          <a:lstStyle xmlns:a="http://schemas.openxmlformats.org/drawingml/2006/main"/>
-          <a:p xmlns:a="http://schemas.openxmlformats.org/drawingml/2006/main">
+          <a:prstGeom prst="rect">
+            <a:avLst/>
+          </a:prstGeom>
+          <a:solidFill>
+            <a:srgbClr val="000000">
+              <a:alpha val="0"/>
+            </a:srgbClr>
+          </a:solidFill>
+          <a:ln w="0">
+            <a:solidFill>
+              <a:srgbClr val="000000">
+                <a:alpha val="0"/>
+              </a:srgbClr>
+            </a:solidFill>
+            <a:prstDash val="solid"/>
+          </a:ln>
+        </ns0:spPr>
+        <ns0:txBody>
+          <a:bodyPr lIns="0" tIns="0" rIns="0" bIns="0" anchor="t"/>
+          <a:lstStyle/>
+          <a:p>
             <a:pPr algn="l">
               <a:defRPr sz="1875" b="1">
                 <a:solidFill>
@@ -8050,48 +8050,48 @@
               <a:t>5,10 mm/día</a:t>
             </a:r>
           </a:p>
-        </p:txBody>
-      </p:sp>
-      <p:sp>
-        <p:nvSpPr>
-          <p:cNvPr id="26" name="">
-            <a:extLst xmlns:a="http://schemas.openxmlformats.org/drawingml/2006/main">
-              <a:ext uri="{FF2B5EF4-FFF2-40B4-BE49-F238E27FC236}">
-                <a16:creationId xmlns:a16="http://schemas.microsoft.com/office/drawing/2014/main" id="{43CC0666-1359-46E2-9190-9455ADECE215}"/>
-              </a:ext>
-            </a:extLst>
-          </p:cNvPr>
-          <p:cNvSpPr>
-            <a:spLocks xmlns:a="http://schemas.openxmlformats.org/drawingml/2006/main" noGrp="1"/>
-          </p:cNvSpPr>
-          <p:nvPr/>
-        </p:nvSpPr>
-        <p:spPr>
-          <a:xfrm xmlns:a="http://schemas.openxmlformats.org/drawingml/2006/main">
+        </ns0:txBody>
+      </ns0:sp>
+      <ns0:sp>
+        <ns0:nvSpPr>
+          <ns0:cNvPr id="26" name="">
+            <a:extLst>
+              <a:ext uri="{FF2B5EF4-FFF2-40B4-BE49-F238E27FC236}">
+                <ns2:creationId id="{43CC0666-1359-46E2-9190-9455ADECE215}"/>
+              </a:ext>
+            </a:extLst>
+          </ns0:cNvPr>
+          <ns0:cNvSpPr>
+            <a:spLocks noGrp="1"/>
+          </ns0:cNvSpPr>
+          <ns0:nvPr/>
+        </ns0:nvSpPr>
+        <ns0:spPr>
+          <a:xfrm>
             <a:off x="857250" y="4467225"/>
             <a:ext cx="1990725" cy="266700"/>
           </a:xfrm>
-          <a:prstGeom xmlns:a="http://schemas.openxmlformats.org/drawingml/2006/main" prst="rect">
-            <a:avLst/>
-          </a:prstGeom>
-          <a:solidFill xmlns:a="http://schemas.openxmlformats.org/drawingml/2006/main">
-            <a:srgbClr val="000000">
-              <a:alpha val="0"/>
-            </a:srgbClr>
-          </a:solidFill>
-          <a:ln xmlns:a="http://schemas.openxmlformats.org/drawingml/2006/main" w="0">
-            <a:solidFill>
-              <a:srgbClr val="000000">
-                <a:alpha val="0"/>
-              </a:srgbClr>
-            </a:solidFill>
-            <a:prstDash val="solid"/>
-          </a:ln>
-        </p:spPr>
-        <p:txBody>
-          <a:bodyPr xmlns:a="http://schemas.openxmlformats.org/drawingml/2006/main" lIns="0" tIns="0" rIns="0" bIns="0" anchor="t"/>
-          <a:lstStyle xmlns:a="http://schemas.openxmlformats.org/drawingml/2006/main"/>
-          <a:p xmlns:a="http://schemas.openxmlformats.org/drawingml/2006/main">
+          <a:prstGeom prst="rect">
+            <a:avLst/>
+          </a:prstGeom>
+          <a:solidFill>
+            <a:srgbClr val="000000">
+              <a:alpha val="0"/>
+            </a:srgbClr>
+          </a:solidFill>
+          <a:ln w="0">
+            <a:solidFill>
+              <a:srgbClr val="000000">
+                <a:alpha val="0"/>
+              </a:srgbClr>
+            </a:solidFill>
+            <a:prstDash val="solid"/>
+          </a:ln>
+        </ns0:spPr>
+        <ns0:txBody>
+          <a:bodyPr lIns="0" tIns="0" rIns="0" bIns="0" anchor="t"/>
+          <a:lstStyle/>
+          <a:p>
             <a:pPr algn="l">
               <a:defRPr sz="900" b="0">
                 <a:solidFill>
@@ -8111,84 +8111,84 @@
                 <a:ea typeface="Aptos"/>
                 <a:cs typeface="Aptos"/>
               </a:rPr>
-              <a:t>Demanda atmosferica media del periodo.</a:t>
-            </a:r>
-          </a:p>
-        </p:txBody>
-      </p:sp>
-      <p:sp>
-        <p:nvSpPr>
-          <p:cNvPr id="27" name="">
-            <a:extLst xmlns:a="http://schemas.openxmlformats.org/drawingml/2006/main">
-              <a:ext uri="{FF2B5EF4-FFF2-40B4-BE49-F238E27FC236}">
-                <a16:creationId xmlns:a16="http://schemas.microsoft.com/office/drawing/2014/main" id="{5A5AA722-45BA-4396-BC86-E1719D9C0F5F}"/>
-              </a:ext>
-            </a:extLst>
-          </p:cNvPr>
-          <p:cNvSpPr>
-            <a:spLocks xmlns:a="http://schemas.openxmlformats.org/drawingml/2006/main" noGrp="1"/>
-          </p:cNvSpPr>
-          <p:nvPr/>
-        </p:nvSpPr>
-        <p:spPr>
-          <a:xfrm xmlns:a="http://schemas.openxmlformats.org/drawingml/2006/main">
+              <a:t>Demanda atmosférica media del periodo.</a:t>
+            </a:r>
+          </a:p>
+        </ns0:txBody>
+      </ns0:sp>
+      <ns0:sp>
+        <ns0:nvSpPr>
+          <ns0:cNvPr id="27" name="">
+            <a:extLst>
+              <a:ext uri="{FF2B5EF4-FFF2-40B4-BE49-F238E27FC236}">
+                <ns2:creationId id="{5A5AA722-45BA-4396-BC86-E1719D9C0F5F}"/>
+              </a:ext>
+            </a:extLst>
+          </ns0:cNvPr>
+          <ns0:cNvSpPr>
+            <a:spLocks noGrp="1"/>
+          </ns0:cNvSpPr>
+          <ns0:nvPr/>
+        </ns0:nvSpPr>
+        <ns0:spPr>
+          <a:xfrm>
             <a:off x="3352800" y="3648075"/>
             <a:ext cx="2333625" cy="1104900"/>
           </a:xfrm>
-          <a:prstGeom xmlns:a="http://schemas.openxmlformats.org/drawingml/2006/main" prst="rect">
-            <a:avLst/>
-          </a:prstGeom>
-          <a:solidFill xmlns:a="http://schemas.openxmlformats.org/drawingml/2006/main">
+          <a:prstGeom prst="rect">
+            <a:avLst/>
+          </a:prstGeom>
+          <a:solidFill>
             <a:srgbClr val="FFFFFF"/>
           </a:solidFill>
-          <a:ln xmlns:a="http://schemas.openxmlformats.org/drawingml/2006/main" w="9525">
+          <a:ln w="9525">
             <a:solidFill>
               <a:srgbClr val="CBD5C7"/>
             </a:solidFill>
             <a:prstDash val="solid"/>
           </a:ln>
-        </p:spPr>
-      </p:sp>
-      <p:sp>
-        <p:nvSpPr>
-          <p:cNvPr id="28" name="">
-            <a:extLst xmlns:a="http://schemas.openxmlformats.org/drawingml/2006/main">
-              <a:ext uri="{FF2B5EF4-FFF2-40B4-BE49-F238E27FC236}">
-                <a16:creationId xmlns:a16="http://schemas.microsoft.com/office/drawing/2014/main" id="{E9A2D394-9A28-4591-8BBD-E2C3CA26ADE1}"/>
-              </a:ext>
-            </a:extLst>
-          </p:cNvPr>
-          <p:cNvSpPr>
-            <a:spLocks xmlns:a="http://schemas.openxmlformats.org/drawingml/2006/main" noGrp="1"/>
-          </p:cNvSpPr>
-          <p:nvPr/>
-        </p:nvSpPr>
-        <p:spPr>
-          <a:xfrm xmlns:a="http://schemas.openxmlformats.org/drawingml/2006/main">
+        </ns0:spPr>
+      </ns0:sp>
+      <ns0:sp>
+        <ns0:nvSpPr>
+          <ns0:cNvPr id="28" name="">
+            <a:extLst>
+              <a:ext uri="{FF2B5EF4-FFF2-40B4-BE49-F238E27FC236}">
+                <ns2:creationId id="{E9A2D394-9A28-4591-8BBD-E2C3CA26ADE1}"/>
+              </a:ext>
+            </a:extLst>
+          </ns0:cNvPr>
+          <ns0:cNvSpPr>
+            <a:spLocks noGrp="1"/>
+          </ns0:cNvSpPr>
+          <ns0:nvPr/>
+        </ns0:nvSpPr>
+        <ns0:spPr>
+          <a:xfrm>
             <a:off x="3524250" y="3800475"/>
             <a:ext cx="1990725" cy="171450"/>
           </a:xfrm>
-          <a:prstGeom xmlns:a="http://schemas.openxmlformats.org/drawingml/2006/main" prst="rect">
-            <a:avLst/>
-          </a:prstGeom>
-          <a:solidFill xmlns:a="http://schemas.openxmlformats.org/drawingml/2006/main">
-            <a:srgbClr val="000000">
-              <a:alpha val="0"/>
-            </a:srgbClr>
-          </a:solidFill>
-          <a:ln xmlns:a="http://schemas.openxmlformats.org/drawingml/2006/main" w="0">
-            <a:solidFill>
-              <a:srgbClr val="000000">
-                <a:alpha val="0"/>
-              </a:srgbClr>
-            </a:solidFill>
-            <a:prstDash val="solid"/>
-          </a:ln>
-        </p:spPr>
-        <p:txBody>
-          <a:bodyPr xmlns:a="http://schemas.openxmlformats.org/drawingml/2006/main" lIns="0" tIns="0" rIns="0" bIns="0" anchor="t"/>
-          <a:lstStyle xmlns:a="http://schemas.openxmlformats.org/drawingml/2006/main"/>
-          <a:p xmlns:a="http://schemas.openxmlformats.org/drawingml/2006/main">
+          <a:prstGeom prst="rect">
+            <a:avLst/>
+          </a:prstGeom>
+          <a:solidFill>
+            <a:srgbClr val="000000">
+              <a:alpha val="0"/>
+            </a:srgbClr>
+          </a:solidFill>
+          <a:ln w="0">
+            <a:solidFill>
+              <a:srgbClr val="000000">
+                <a:alpha val="0"/>
+              </a:srgbClr>
+            </a:solidFill>
+            <a:prstDash val="solid"/>
+          </a:ln>
+        </ns0:spPr>
+        <ns0:txBody>
+          <a:bodyPr lIns="0" tIns="0" rIns="0" bIns="0" anchor="t"/>
+          <a:lstStyle/>
+          <a:p>
             <a:pPr algn="l">
               <a:defRPr sz="975" b="1">
                 <a:solidFill>
@@ -8211,48 +8211,48 @@
               <a:t>Lluvia total</a:t>
             </a:r>
           </a:p>
-        </p:txBody>
-      </p:sp>
-      <p:sp>
-        <p:nvSpPr>
-          <p:cNvPr id="29" name="">
-            <a:extLst xmlns:a="http://schemas.openxmlformats.org/drawingml/2006/main">
-              <a:ext uri="{FF2B5EF4-FFF2-40B4-BE49-F238E27FC236}">
-                <a16:creationId xmlns:a16="http://schemas.microsoft.com/office/drawing/2014/main" id="{E159C21E-29F6-4D31-90F0-48AA534F78B3}"/>
-              </a:ext>
-            </a:extLst>
-          </p:cNvPr>
-          <p:cNvSpPr>
-            <a:spLocks xmlns:a="http://schemas.openxmlformats.org/drawingml/2006/main" noGrp="1"/>
-          </p:cNvSpPr>
-          <p:nvPr/>
-        </p:nvSpPr>
-        <p:spPr>
-          <a:xfrm xmlns:a="http://schemas.openxmlformats.org/drawingml/2006/main">
+        </ns0:txBody>
+      </ns0:sp>
+      <ns0:sp>
+        <ns0:nvSpPr>
+          <ns0:cNvPr id="29" name="">
+            <a:extLst>
+              <a:ext uri="{FF2B5EF4-FFF2-40B4-BE49-F238E27FC236}">
+                <ns2:creationId id="{E159C21E-29F6-4D31-90F0-48AA534F78B3}"/>
+              </a:ext>
+            </a:extLst>
+          </ns0:cNvPr>
+          <ns0:cNvSpPr>
+            <a:spLocks noGrp="1"/>
+          </ns0:cNvSpPr>
+          <ns0:nvPr/>
+        </ns0:nvSpPr>
+        <ns0:spPr>
+          <a:xfrm>
             <a:off x="3524250" y="4029075"/>
             <a:ext cx="1990725" cy="400050"/>
           </a:xfrm>
-          <a:prstGeom xmlns:a="http://schemas.openxmlformats.org/drawingml/2006/main" prst="rect">
-            <a:avLst/>
-          </a:prstGeom>
-          <a:solidFill xmlns:a="http://schemas.openxmlformats.org/drawingml/2006/main">
-            <a:srgbClr val="000000">
-              <a:alpha val="0"/>
-            </a:srgbClr>
-          </a:solidFill>
-          <a:ln xmlns:a="http://schemas.openxmlformats.org/drawingml/2006/main" w="0">
-            <a:solidFill>
-              <a:srgbClr val="000000">
-                <a:alpha val="0"/>
-              </a:srgbClr>
-            </a:solidFill>
-            <a:prstDash val="solid"/>
-          </a:ln>
-        </p:spPr>
-        <p:txBody>
-          <a:bodyPr xmlns:a="http://schemas.openxmlformats.org/drawingml/2006/main" lIns="0" tIns="0" rIns="0" bIns="0" anchor="t"/>
-          <a:lstStyle xmlns:a="http://schemas.openxmlformats.org/drawingml/2006/main"/>
-          <a:p xmlns:a="http://schemas.openxmlformats.org/drawingml/2006/main">
+          <a:prstGeom prst="rect">
+            <a:avLst/>
+          </a:prstGeom>
+          <a:solidFill>
+            <a:srgbClr val="000000">
+              <a:alpha val="0"/>
+            </a:srgbClr>
+          </a:solidFill>
+          <a:ln w="0">
+            <a:solidFill>
+              <a:srgbClr val="000000">
+                <a:alpha val="0"/>
+              </a:srgbClr>
+            </a:solidFill>
+            <a:prstDash val="solid"/>
+          </a:ln>
+        </ns0:spPr>
+        <ns0:txBody>
+          <a:bodyPr lIns="0" tIns="0" rIns="0" bIns="0" anchor="t"/>
+          <a:lstStyle/>
+          <a:p>
             <a:pPr algn="l">
               <a:defRPr sz="2175" b="1">
                 <a:solidFill>
@@ -8275,48 +8275,48 @@
               <a:t>0,00 mm</a:t>
             </a:r>
           </a:p>
-        </p:txBody>
-      </p:sp>
-      <p:sp>
-        <p:nvSpPr>
-          <p:cNvPr id="30" name="">
-            <a:extLst xmlns:a="http://schemas.openxmlformats.org/drawingml/2006/main">
-              <a:ext uri="{FF2B5EF4-FFF2-40B4-BE49-F238E27FC236}">
-                <a16:creationId xmlns:a16="http://schemas.microsoft.com/office/drawing/2014/main" id="{064940AA-ED70-4AAD-9000-3352DFC5346E}"/>
-              </a:ext>
-            </a:extLst>
-          </p:cNvPr>
-          <p:cNvSpPr>
-            <a:spLocks xmlns:a="http://schemas.openxmlformats.org/drawingml/2006/main" noGrp="1"/>
-          </p:cNvSpPr>
-          <p:nvPr/>
-        </p:nvSpPr>
-        <p:spPr>
-          <a:xfrm xmlns:a="http://schemas.openxmlformats.org/drawingml/2006/main">
+        </ns0:txBody>
+      </ns0:sp>
+      <ns0:sp>
+        <ns0:nvSpPr>
+          <ns0:cNvPr id="30" name="">
+            <a:extLst>
+              <a:ext uri="{FF2B5EF4-FFF2-40B4-BE49-F238E27FC236}">
+                <ns2:creationId id="{064940AA-ED70-4AAD-9000-3352DFC5346E}"/>
+              </a:ext>
+            </a:extLst>
+          </ns0:cNvPr>
+          <ns0:cNvSpPr>
+            <a:spLocks noGrp="1"/>
+          </ns0:cNvSpPr>
+          <ns0:nvPr/>
+        </ns0:nvSpPr>
+        <ns0:spPr>
+          <a:xfrm>
             <a:off x="3524250" y="4467225"/>
             <a:ext cx="1990725" cy="266700"/>
           </a:xfrm>
-          <a:prstGeom xmlns:a="http://schemas.openxmlformats.org/drawingml/2006/main" prst="rect">
-            <a:avLst/>
-          </a:prstGeom>
-          <a:solidFill xmlns:a="http://schemas.openxmlformats.org/drawingml/2006/main">
-            <a:srgbClr val="000000">
-              <a:alpha val="0"/>
-            </a:srgbClr>
-          </a:solidFill>
-          <a:ln xmlns:a="http://schemas.openxmlformats.org/drawingml/2006/main" w="0">
-            <a:solidFill>
-              <a:srgbClr val="000000">
-                <a:alpha val="0"/>
-              </a:srgbClr>
-            </a:solidFill>
-            <a:prstDash val="solid"/>
-          </a:ln>
-        </p:spPr>
-        <p:txBody>
-          <a:bodyPr xmlns:a="http://schemas.openxmlformats.org/drawingml/2006/main" lIns="0" tIns="0" rIns="0" bIns="0" anchor="t"/>
-          <a:lstStyle xmlns:a="http://schemas.openxmlformats.org/drawingml/2006/main"/>
-          <a:p xmlns:a="http://schemas.openxmlformats.org/drawingml/2006/main">
+          <a:prstGeom prst="rect">
+            <a:avLst/>
+          </a:prstGeom>
+          <a:solidFill>
+            <a:srgbClr val="000000">
+              <a:alpha val="0"/>
+            </a:srgbClr>
+          </a:solidFill>
+          <a:ln w="0">
+            <a:solidFill>
+              <a:srgbClr val="000000">
+                <a:alpha val="0"/>
+              </a:srgbClr>
+            </a:solidFill>
+            <a:prstDash val="solid"/>
+          </a:ln>
+        </ns0:spPr>
+        <ns0:txBody>
+          <a:bodyPr lIns="0" tIns="0" rIns="0" bIns="0" anchor="t"/>
+          <a:lstStyle/>
+          <a:p>
             <a:pPr algn="l">
               <a:defRPr sz="900" b="0">
                 <a:solidFill>
@@ -8339,81 +8339,81 @@
               <a:t>No reduce la necesidad de riego.</a:t>
             </a:r>
           </a:p>
-        </p:txBody>
-      </p:sp>
-      <p:sp>
-        <p:nvSpPr>
-          <p:cNvPr id="31" name="">
-            <a:extLst xmlns:a="http://schemas.openxmlformats.org/drawingml/2006/main">
-              <a:ext uri="{FF2B5EF4-FFF2-40B4-BE49-F238E27FC236}">
-                <a16:creationId xmlns:a16="http://schemas.microsoft.com/office/drawing/2014/main" id="{D0171A5D-B8BF-448E-B653-88990E8D7865}"/>
-              </a:ext>
-            </a:extLst>
-          </p:cNvPr>
-          <p:cNvSpPr>
-            <a:spLocks xmlns:a="http://schemas.openxmlformats.org/drawingml/2006/main" noGrp="1"/>
-          </p:cNvSpPr>
-          <p:nvPr/>
-        </p:nvSpPr>
-        <p:spPr>
-          <a:xfrm xmlns:a="http://schemas.openxmlformats.org/drawingml/2006/main">
+        </ns0:txBody>
+      </ns0:sp>
+      <ns0:sp>
+        <ns0:nvSpPr>
+          <ns0:cNvPr id="31" name="">
+            <a:extLst>
+              <a:ext uri="{FF2B5EF4-FFF2-40B4-BE49-F238E27FC236}">
+                <ns2:creationId id="{D0171A5D-B8BF-448E-B653-88990E8D7865}"/>
+              </a:ext>
+            </a:extLst>
+          </ns0:cNvPr>
+          <ns0:cNvSpPr>
+            <a:spLocks noGrp="1"/>
+          </ns0:cNvSpPr>
+          <ns0:nvPr/>
+        </ns0:nvSpPr>
+        <ns0:spPr>
+          <a:xfrm>
             <a:off x="6019800" y="3648075"/>
             <a:ext cx="2333625" cy="1104900"/>
           </a:xfrm>
-          <a:prstGeom xmlns:a="http://schemas.openxmlformats.org/drawingml/2006/main" prst="rect">
-            <a:avLst/>
-          </a:prstGeom>
-          <a:solidFill xmlns:a="http://schemas.openxmlformats.org/drawingml/2006/main">
+          <a:prstGeom prst="rect">
+            <a:avLst/>
+          </a:prstGeom>
+          <a:solidFill>
             <a:srgbClr val="FFFFFF"/>
           </a:solidFill>
-          <a:ln xmlns:a="http://schemas.openxmlformats.org/drawingml/2006/main" w="9525">
+          <a:ln w="9525">
             <a:solidFill>
               <a:srgbClr val="CBD5C7"/>
             </a:solidFill>
             <a:prstDash val="solid"/>
           </a:ln>
-        </p:spPr>
-      </p:sp>
-      <p:sp>
-        <p:nvSpPr>
-          <p:cNvPr id="32" name="">
-            <a:extLst xmlns:a="http://schemas.openxmlformats.org/drawingml/2006/main">
-              <a:ext uri="{FF2B5EF4-FFF2-40B4-BE49-F238E27FC236}">
-                <a16:creationId xmlns:a16="http://schemas.microsoft.com/office/drawing/2014/main" id="{F63C0A47-AA86-44E6-9F6C-5587E09C4872}"/>
-              </a:ext>
-            </a:extLst>
-          </p:cNvPr>
-          <p:cNvSpPr>
-            <a:spLocks xmlns:a="http://schemas.openxmlformats.org/drawingml/2006/main" noGrp="1"/>
-          </p:cNvSpPr>
-          <p:nvPr/>
-        </p:nvSpPr>
-        <p:spPr>
-          <a:xfrm xmlns:a="http://schemas.openxmlformats.org/drawingml/2006/main">
+        </ns0:spPr>
+      </ns0:sp>
+      <ns0:sp>
+        <ns0:nvSpPr>
+          <ns0:cNvPr id="32" name="">
+            <a:extLst>
+              <a:ext uri="{FF2B5EF4-FFF2-40B4-BE49-F238E27FC236}">
+                <ns2:creationId id="{F63C0A47-AA86-44E6-9F6C-5587E09C4872}"/>
+              </a:ext>
+            </a:extLst>
+          </ns0:cNvPr>
+          <ns0:cNvSpPr>
+            <a:spLocks noGrp="1"/>
+          </ns0:cNvSpPr>
+          <ns0:nvPr/>
+        </ns0:nvSpPr>
+        <ns0:spPr>
+          <a:xfrm>
             <a:off x="6191250" y="3800475"/>
             <a:ext cx="1990725" cy="171450"/>
           </a:xfrm>
-          <a:prstGeom xmlns:a="http://schemas.openxmlformats.org/drawingml/2006/main" prst="rect">
-            <a:avLst/>
-          </a:prstGeom>
-          <a:solidFill xmlns:a="http://schemas.openxmlformats.org/drawingml/2006/main">
-            <a:srgbClr val="000000">
-              <a:alpha val="0"/>
-            </a:srgbClr>
-          </a:solidFill>
-          <a:ln xmlns:a="http://schemas.openxmlformats.org/drawingml/2006/main" w="0">
-            <a:solidFill>
-              <a:srgbClr val="000000">
-                <a:alpha val="0"/>
-              </a:srgbClr>
-            </a:solidFill>
-            <a:prstDash val="solid"/>
-          </a:ln>
-        </p:spPr>
-        <p:txBody>
-          <a:bodyPr xmlns:a="http://schemas.openxmlformats.org/drawingml/2006/main" lIns="0" tIns="0" rIns="0" bIns="0" anchor="t"/>
-          <a:lstStyle xmlns:a="http://schemas.openxmlformats.org/drawingml/2006/main"/>
-          <a:p xmlns:a="http://schemas.openxmlformats.org/drawingml/2006/main">
+          <a:prstGeom prst="rect">
+            <a:avLst/>
+          </a:prstGeom>
+          <a:solidFill>
+            <a:srgbClr val="000000">
+              <a:alpha val="0"/>
+            </a:srgbClr>
+          </a:solidFill>
+          <a:ln w="0">
+            <a:solidFill>
+              <a:srgbClr val="000000">
+                <a:alpha val="0"/>
+              </a:srgbClr>
+            </a:solidFill>
+            <a:prstDash val="solid"/>
+          </a:ln>
+        </ns0:spPr>
+        <ns0:txBody>
+          <a:bodyPr lIns="0" tIns="0" rIns="0" bIns="0" anchor="t"/>
+          <a:lstStyle/>
+          <a:p>
             <a:pPr algn="l">
               <a:defRPr sz="975" b="1">
                 <a:solidFill>
@@ -8436,48 +8436,48 @@
               <a:t>Predicción ML</a:t>
             </a:r>
           </a:p>
-        </p:txBody>
-      </p:sp>
-      <p:sp>
-        <p:nvSpPr>
-          <p:cNvPr id="33" name="">
-            <a:extLst xmlns:a="http://schemas.openxmlformats.org/drawingml/2006/main">
-              <a:ext uri="{FF2B5EF4-FFF2-40B4-BE49-F238E27FC236}">
-                <a16:creationId xmlns:a16="http://schemas.microsoft.com/office/drawing/2014/main" id="{60411B08-24D7-4A5B-9E5F-E93846A13AC7}"/>
-              </a:ext>
-            </a:extLst>
-          </p:cNvPr>
-          <p:cNvSpPr>
-            <a:spLocks xmlns:a="http://schemas.openxmlformats.org/drawingml/2006/main" noGrp="1"/>
-          </p:cNvSpPr>
-          <p:nvPr/>
-        </p:nvSpPr>
-        <p:spPr>
-          <a:xfrm xmlns:a="http://schemas.openxmlformats.org/drawingml/2006/main">
+        </ns0:txBody>
+      </ns0:sp>
+      <ns0:sp>
+        <ns0:nvSpPr>
+          <ns0:cNvPr id="33" name="">
+            <a:extLst>
+              <a:ext uri="{FF2B5EF4-FFF2-40B4-BE49-F238E27FC236}">
+                <ns2:creationId id="{60411B08-24D7-4A5B-9E5F-E93846A13AC7}"/>
+              </a:ext>
+            </a:extLst>
+          </ns0:cNvPr>
+          <ns0:cNvSpPr>
+            <a:spLocks noGrp="1"/>
+          </ns0:cNvSpPr>
+          <ns0:nvPr/>
+        </ns0:nvSpPr>
+        <ns0:spPr>
+          <a:xfrm>
             <a:off x="6191250" y="4029075"/>
             <a:ext cx="1990725" cy="400050"/>
           </a:xfrm>
-          <a:prstGeom xmlns:a="http://schemas.openxmlformats.org/drawingml/2006/main" prst="rect">
-            <a:avLst/>
-          </a:prstGeom>
-          <a:solidFill xmlns:a="http://schemas.openxmlformats.org/drawingml/2006/main">
-            <a:srgbClr val="000000">
-              <a:alpha val="0"/>
-            </a:srgbClr>
-          </a:solidFill>
-          <a:ln xmlns:a="http://schemas.openxmlformats.org/drawingml/2006/main" w="0">
-            <a:solidFill>
-              <a:srgbClr val="000000">
-                <a:alpha val="0"/>
-              </a:srgbClr>
-            </a:solidFill>
-            <a:prstDash val="solid"/>
-          </a:ln>
-        </p:spPr>
-        <p:txBody>
-          <a:bodyPr xmlns:a="http://schemas.openxmlformats.org/drawingml/2006/main" lIns="0" tIns="0" rIns="0" bIns="0" anchor="t"/>
-          <a:lstStyle xmlns:a="http://schemas.openxmlformats.org/drawingml/2006/main"/>
-          <a:p xmlns:a="http://schemas.openxmlformats.org/drawingml/2006/main">
+          <a:prstGeom prst="rect">
+            <a:avLst/>
+          </a:prstGeom>
+          <a:solidFill>
+            <a:srgbClr val="000000">
+              <a:alpha val="0"/>
+            </a:srgbClr>
+          </a:solidFill>
+          <a:ln w="0">
+            <a:solidFill>
+              <a:srgbClr val="000000">
+                <a:alpha val="0"/>
+              </a:srgbClr>
+            </a:solidFill>
+            <a:prstDash val="solid"/>
+          </a:ln>
+        </ns0:spPr>
+        <ns0:txBody>
+          <a:bodyPr lIns="0" tIns="0" rIns="0" bIns="0" anchor="t"/>
+          <a:lstStyle/>
+          <a:p>
             <a:pPr algn="l">
               <a:defRPr sz="2175" b="1">
                 <a:solidFill>
@@ -8500,48 +8500,48 @@
               <a:t>97.160 L</a:t>
             </a:r>
           </a:p>
-        </p:txBody>
-      </p:sp>
-      <p:sp>
-        <p:nvSpPr>
-          <p:cNvPr id="34" name="">
-            <a:extLst xmlns:a="http://schemas.openxmlformats.org/drawingml/2006/main">
-              <a:ext uri="{FF2B5EF4-FFF2-40B4-BE49-F238E27FC236}">
-                <a16:creationId xmlns:a16="http://schemas.microsoft.com/office/drawing/2014/main" id="{21F21FCA-8067-4466-99D0-A42F3310B6D6}"/>
-              </a:ext>
-            </a:extLst>
-          </p:cNvPr>
-          <p:cNvSpPr>
-            <a:spLocks xmlns:a="http://schemas.openxmlformats.org/drawingml/2006/main" noGrp="1"/>
-          </p:cNvSpPr>
-          <p:nvPr/>
-        </p:nvSpPr>
-        <p:spPr>
-          <a:xfrm xmlns:a="http://schemas.openxmlformats.org/drawingml/2006/main">
+        </ns0:txBody>
+      </ns0:sp>
+      <ns0:sp>
+        <ns0:nvSpPr>
+          <ns0:cNvPr id="34" name="">
+            <a:extLst>
+              <a:ext uri="{FF2B5EF4-FFF2-40B4-BE49-F238E27FC236}">
+                <ns2:creationId id="{21F21FCA-8067-4466-99D0-A42F3310B6D6}"/>
+              </a:ext>
+            </a:extLst>
+          </ns0:cNvPr>
+          <ns0:cNvSpPr>
+            <a:spLocks noGrp="1"/>
+          </ns0:cNvSpPr>
+          <ns0:nvPr/>
+        </ns0:nvSpPr>
+        <ns0:spPr>
+          <a:xfrm>
             <a:off x="6191250" y="4467225"/>
             <a:ext cx="1990725" cy="266700"/>
           </a:xfrm>
-          <a:prstGeom xmlns:a="http://schemas.openxmlformats.org/drawingml/2006/main" prst="rect">
-            <a:avLst/>
-          </a:prstGeom>
-          <a:solidFill xmlns:a="http://schemas.openxmlformats.org/drawingml/2006/main">
-            <a:srgbClr val="000000">
-              <a:alpha val="0"/>
-            </a:srgbClr>
-          </a:solidFill>
-          <a:ln xmlns:a="http://schemas.openxmlformats.org/drawingml/2006/main" w="0">
-            <a:solidFill>
-              <a:srgbClr val="000000">
-                <a:alpha val="0"/>
-              </a:srgbClr>
-            </a:solidFill>
-            <a:prstDash val="solid"/>
-          </a:ln>
-        </p:spPr>
-        <p:txBody>
-          <a:bodyPr xmlns:a="http://schemas.openxmlformats.org/drawingml/2006/main" lIns="0" tIns="0" rIns="0" bIns="0" anchor="t"/>
-          <a:lstStyle xmlns:a="http://schemas.openxmlformats.org/drawingml/2006/main"/>
-          <a:p xmlns:a="http://schemas.openxmlformats.org/drawingml/2006/main">
+          <a:prstGeom prst="rect">
+            <a:avLst/>
+          </a:prstGeom>
+          <a:solidFill>
+            <a:srgbClr val="000000">
+              <a:alpha val="0"/>
+            </a:srgbClr>
+          </a:solidFill>
+          <a:ln w="0">
+            <a:solidFill>
+              <a:srgbClr val="000000">
+                <a:alpha val="0"/>
+              </a:srgbClr>
+            </a:solidFill>
+            <a:prstDash val="solid"/>
+          </a:ln>
+        </ns0:spPr>
+        <ns0:txBody>
+          <a:bodyPr lIns="0" tIns="0" rIns="0" bIns="0" anchor="t"/>
+          <a:lstStyle/>
+          <a:p>
             <a:pPr algn="l">
               <a:defRPr sz="900" b="0">
                 <a:solidFill>
@@ -8564,81 +8564,81 @@
               <a:t>Resultado muy cercano al cálculo base.</a:t>
             </a:r>
           </a:p>
-        </p:txBody>
-      </p:sp>
-      <p:sp>
-        <p:nvSpPr>
-          <p:cNvPr id="35" name="">
-            <a:extLst xmlns:a="http://schemas.openxmlformats.org/drawingml/2006/main">
-              <a:ext uri="{FF2B5EF4-FFF2-40B4-BE49-F238E27FC236}">
-                <a16:creationId xmlns:a16="http://schemas.microsoft.com/office/drawing/2014/main" id="{41794ABC-6C1B-4E70-9312-05F016BDB97D}"/>
-              </a:ext>
-            </a:extLst>
-          </p:cNvPr>
-          <p:cNvSpPr>
-            <a:spLocks xmlns:a="http://schemas.openxmlformats.org/drawingml/2006/main" noGrp="1"/>
-          </p:cNvSpPr>
-          <p:nvPr/>
-        </p:nvSpPr>
-        <p:spPr>
-          <a:xfrm xmlns:a="http://schemas.openxmlformats.org/drawingml/2006/main">
+        </ns0:txBody>
+      </ns0:sp>
+      <ns0:sp>
+        <ns0:nvSpPr>
+          <ns0:cNvPr id="35" name="">
+            <a:extLst>
+              <a:ext uri="{FF2B5EF4-FFF2-40B4-BE49-F238E27FC236}">
+                <ns2:creationId id="{41794ABC-6C1B-4E70-9312-05F016BDB97D}"/>
+              </a:ext>
+            </a:extLst>
+          </ns0:cNvPr>
+          <ns0:cNvSpPr>
+            <a:spLocks noGrp="1"/>
+          </ns0:cNvSpPr>
+          <ns0:nvPr/>
+        </ns0:nvSpPr>
+        <ns0:spPr>
+          <a:xfrm>
             <a:off x="8686800" y="3648075"/>
             <a:ext cx="2333625" cy="1104900"/>
           </a:xfrm>
-          <a:prstGeom xmlns:a="http://schemas.openxmlformats.org/drawingml/2006/main" prst="rect">
-            <a:avLst/>
-          </a:prstGeom>
-          <a:solidFill xmlns:a="http://schemas.openxmlformats.org/drawingml/2006/main">
+          <a:prstGeom prst="rect">
+            <a:avLst/>
+          </a:prstGeom>
+          <a:solidFill>
             <a:srgbClr val="FFFFFF"/>
           </a:solidFill>
-          <a:ln xmlns:a="http://schemas.openxmlformats.org/drawingml/2006/main" w="9525">
+          <a:ln w="9525">
             <a:solidFill>
               <a:srgbClr val="CBD5C7"/>
             </a:solidFill>
             <a:prstDash val="solid"/>
           </a:ln>
-        </p:spPr>
-      </p:sp>
-      <p:sp>
-        <p:nvSpPr>
-          <p:cNvPr id="36" name="">
-            <a:extLst xmlns:a="http://schemas.openxmlformats.org/drawingml/2006/main">
-              <a:ext uri="{FF2B5EF4-FFF2-40B4-BE49-F238E27FC236}">
-                <a16:creationId xmlns:a16="http://schemas.microsoft.com/office/drawing/2014/main" id="{B8F6FCFE-9CDF-45CB-AA0F-D6E039721751}"/>
-              </a:ext>
-            </a:extLst>
-          </p:cNvPr>
-          <p:cNvSpPr>
-            <a:spLocks xmlns:a="http://schemas.openxmlformats.org/drawingml/2006/main" noGrp="1"/>
-          </p:cNvSpPr>
-          <p:nvPr/>
-        </p:nvSpPr>
-        <p:spPr>
-          <a:xfrm xmlns:a="http://schemas.openxmlformats.org/drawingml/2006/main">
+        </ns0:spPr>
+      </ns0:sp>
+      <ns0:sp>
+        <ns0:nvSpPr>
+          <ns0:cNvPr id="36" name="">
+            <a:extLst>
+              <a:ext uri="{FF2B5EF4-FFF2-40B4-BE49-F238E27FC236}">
+                <ns2:creationId id="{B8F6FCFE-9CDF-45CB-AA0F-D6E039721751}"/>
+              </a:ext>
+            </a:extLst>
+          </ns0:cNvPr>
+          <ns0:cNvSpPr>
+            <a:spLocks noGrp="1"/>
+          </ns0:cNvSpPr>
+          <ns0:nvPr/>
+        </ns0:nvSpPr>
+        <ns0:spPr>
+          <a:xfrm>
             <a:off x="8858250" y="3800475"/>
             <a:ext cx="1990725" cy="171450"/>
           </a:xfrm>
-          <a:prstGeom xmlns:a="http://schemas.openxmlformats.org/drawingml/2006/main" prst="rect">
-            <a:avLst/>
-          </a:prstGeom>
-          <a:solidFill xmlns:a="http://schemas.openxmlformats.org/drawingml/2006/main">
-            <a:srgbClr val="000000">
-              <a:alpha val="0"/>
-            </a:srgbClr>
-          </a:solidFill>
-          <a:ln xmlns:a="http://schemas.openxmlformats.org/drawingml/2006/main" w="0">
-            <a:solidFill>
-              <a:srgbClr val="000000">
-                <a:alpha val="0"/>
-              </a:srgbClr>
-            </a:solidFill>
-            <a:prstDash val="solid"/>
-          </a:ln>
-        </p:spPr>
-        <p:txBody>
-          <a:bodyPr xmlns:a="http://schemas.openxmlformats.org/drawingml/2006/main" lIns="0" tIns="0" rIns="0" bIns="0" anchor="t"/>
-          <a:lstStyle xmlns:a="http://schemas.openxmlformats.org/drawingml/2006/main"/>
-          <a:p xmlns:a="http://schemas.openxmlformats.org/drawingml/2006/main">
+          <a:prstGeom prst="rect">
+            <a:avLst/>
+          </a:prstGeom>
+          <a:solidFill>
+            <a:srgbClr val="000000">
+              <a:alpha val="0"/>
+            </a:srgbClr>
+          </a:solidFill>
+          <a:ln w="0">
+            <a:solidFill>
+              <a:srgbClr val="000000">
+                <a:alpha val="0"/>
+              </a:srgbClr>
+            </a:solidFill>
+            <a:prstDash val="solid"/>
+          </a:ln>
+        </ns0:spPr>
+        <ns0:txBody>
+          <a:bodyPr lIns="0" tIns="0" rIns="0" bIns="0" anchor="t"/>
+          <a:lstStyle/>
+          <a:p>
             <a:pPr algn="l">
               <a:defRPr sz="975" b="1">
                 <a:solidFill>
@@ -8658,51 +8658,51 @@
                 <a:ea typeface="Aptos"/>
                 <a:cs typeface="Aptos"/>
               </a:rPr>
-              <a:t>Modelo</a:t>
-            </a:r>
-          </a:p>
-        </p:txBody>
-      </p:sp>
-      <p:sp>
-        <p:nvSpPr>
-          <p:cNvPr id="37" name="">
-            <a:extLst xmlns:a="http://schemas.openxmlformats.org/drawingml/2006/main">
-              <a:ext uri="{FF2B5EF4-FFF2-40B4-BE49-F238E27FC236}">
-                <a16:creationId xmlns:a16="http://schemas.microsoft.com/office/drawing/2014/main" id="{14689882-0056-48D0-B4F4-9C1FAD210E73}"/>
-              </a:ext>
-            </a:extLst>
-          </p:cNvPr>
-          <p:cNvSpPr>
-            <a:spLocks xmlns:a="http://schemas.openxmlformats.org/drawingml/2006/main" noGrp="1"/>
-          </p:cNvSpPr>
-          <p:nvPr/>
-        </p:nvSpPr>
-        <p:spPr>
-          <a:xfrm xmlns:a="http://schemas.openxmlformats.org/drawingml/2006/main">
+              <a:t>ETc media</a:t>
+            </a:r>
+          </a:p>
+        </ns0:txBody>
+      </ns0:sp>
+      <ns0:sp>
+        <ns0:nvSpPr>
+          <ns0:cNvPr id="37" name="">
+            <a:extLst>
+              <a:ext uri="{FF2B5EF4-FFF2-40B4-BE49-F238E27FC236}">
+                <ns2:creationId id="{14689882-0056-48D0-B4F4-9C1FAD210E73}"/>
+              </a:ext>
+            </a:extLst>
+          </ns0:cNvPr>
+          <ns0:cNvSpPr>
+            <a:spLocks noGrp="1"/>
+          </ns0:cNvSpPr>
+          <ns0:nvPr/>
+        </ns0:nvSpPr>
+        <ns0:spPr>
+          <a:xfrm>
             <a:off x="8858250" y="4029075"/>
             <a:ext cx="1990725" cy="400050"/>
           </a:xfrm>
-          <a:prstGeom xmlns:a="http://schemas.openxmlformats.org/drawingml/2006/main" prst="rect">
-            <a:avLst/>
-          </a:prstGeom>
-          <a:solidFill xmlns:a="http://schemas.openxmlformats.org/drawingml/2006/main">
-            <a:srgbClr val="000000">
-              <a:alpha val="0"/>
-            </a:srgbClr>
-          </a:solidFill>
-          <a:ln xmlns:a="http://schemas.openxmlformats.org/drawingml/2006/main" w="0">
-            <a:solidFill>
-              <a:srgbClr val="000000">
-                <a:alpha val="0"/>
-              </a:srgbClr>
-            </a:solidFill>
-            <a:prstDash val="solid"/>
-          </a:ln>
-        </p:spPr>
-        <p:txBody>
-          <a:bodyPr xmlns:a="http://schemas.openxmlformats.org/drawingml/2006/main" lIns="0" tIns="0" rIns="0" bIns="0" anchor="t"/>
-          <a:lstStyle xmlns:a="http://schemas.openxmlformats.org/drawingml/2006/main"/>
-          <a:p xmlns:a="http://schemas.openxmlformats.org/drawingml/2006/main">
+          <a:prstGeom prst="rect">
+            <a:avLst/>
+          </a:prstGeom>
+          <a:solidFill>
+            <a:srgbClr val="000000">
+              <a:alpha val="0"/>
+            </a:srgbClr>
+          </a:solidFill>
+          <a:ln w="0">
+            <a:solidFill>
+              <a:srgbClr val="000000">
+                <a:alpha val="0"/>
+              </a:srgbClr>
+            </a:solidFill>
+            <a:prstDash val="solid"/>
+          </a:ln>
+        </ns0:spPr>
+        <ns0:txBody>
+          <a:bodyPr lIns="0" tIns="0" rIns="0" bIns="0" anchor="t"/>
+          <a:lstStyle/>
+          <a:p>
             <a:pPr algn="l">
               <a:defRPr sz="2175" b="1">
                 <a:solidFill>
@@ -8722,51 +8722,51 @@
                 <a:ea typeface="Aptos Display"/>
                 <a:cs typeface="Aptos Display"/>
               </a:rPr>
-              <a:t>R2 0,9755</a:t>
-            </a:r>
-          </a:p>
-        </p:txBody>
-      </p:sp>
-      <p:sp>
-        <p:nvSpPr>
-          <p:cNvPr id="38" name="">
-            <a:extLst xmlns:a="http://schemas.openxmlformats.org/drawingml/2006/main">
-              <a:ext uri="{FF2B5EF4-FFF2-40B4-BE49-F238E27FC236}">
-                <a16:creationId xmlns:a16="http://schemas.microsoft.com/office/drawing/2014/main" id="{3E115C5E-ACD8-4F89-AA54-6AC79C50B457}"/>
-              </a:ext>
-            </a:extLst>
-          </p:cNvPr>
-          <p:cNvSpPr>
-            <a:spLocks xmlns:a="http://schemas.openxmlformats.org/drawingml/2006/main" noGrp="1"/>
-          </p:cNvSpPr>
-          <p:nvPr/>
-        </p:nvSpPr>
-        <p:spPr>
-          <a:xfrm xmlns:a="http://schemas.openxmlformats.org/drawingml/2006/main">
+              <a:t>3,57 mm/día</a:t>
+            </a:r>
+          </a:p>
+        </ns0:txBody>
+      </ns0:sp>
+      <ns0:sp>
+        <ns0:nvSpPr>
+          <ns0:cNvPr id="38" name="">
+            <a:extLst>
+              <a:ext uri="{FF2B5EF4-FFF2-40B4-BE49-F238E27FC236}">
+                <ns2:creationId id="{3E115C5E-ACD8-4F89-AA54-6AC79C50B457}"/>
+              </a:ext>
+            </a:extLst>
+          </ns0:cNvPr>
+          <ns0:cNvSpPr>
+            <a:spLocks noGrp="1"/>
+          </ns0:cNvSpPr>
+          <ns0:nvPr/>
+        </ns0:nvSpPr>
+        <ns0:spPr>
+          <a:xfrm>
             <a:off x="8858250" y="4467225"/>
             <a:ext cx="1990725" cy="266700"/>
           </a:xfrm>
-          <a:prstGeom xmlns:a="http://schemas.openxmlformats.org/drawingml/2006/main" prst="rect">
-            <a:avLst/>
-          </a:prstGeom>
-          <a:solidFill xmlns:a="http://schemas.openxmlformats.org/drawingml/2006/main">
-            <a:srgbClr val="000000">
-              <a:alpha val="0"/>
-            </a:srgbClr>
-          </a:solidFill>
-          <a:ln xmlns:a="http://schemas.openxmlformats.org/drawingml/2006/main" w="0">
-            <a:solidFill>
-              <a:srgbClr val="000000">
-                <a:alpha val="0"/>
-              </a:srgbClr>
-            </a:solidFill>
-            <a:prstDash val="solid"/>
-          </a:ln>
-        </p:spPr>
-        <p:txBody>
-          <a:bodyPr xmlns:a="http://schemas.openxmlformats.org/drawingml/2006/main" lIns="0" tIns="0" rIns="0" bIns="0" anchor="t"/>
-          <a:lstStyle xmlns:a="http://schemas.openxmlformats.org/drawingml/2006/main"/>
-          <a:p xmlns:a="http://schemas.openxmlformats.org/drawingml/2006/main">
+          <a:prstGeom prst="rect">
+            <a:avLst/>
+          </a:prstGeom>
+          <a:solidFill>
+            <a:srgbClr val="000000">
+              <a:alpha val="0"/>
+            </a:srgbClr>
+          </a:solidFill>
+          <a:ln w="0">
+            <a:solidFill>
+              <a:srgbClr val="000000">
+                <a:alpha val="0"/>
+              </a:srgbClr>
+            </a:solidFill>
+            <a:prstDash val="solid"/>
+          </a:ln>
+        </ns0:spPr>
+        <ns0:txBody>
+          <a:bodyPr lIns="0" tIns="0" rIns="0" bIns="0" anchor="t"/>
+          <a:lstStyle/>
+          <a:p>
             <a:pPr algn="l">
               <a:defRPr sz="900" b="0">
                 <a:solidFill>
@@ -8786,51 +8786,51 @@
                 <a:ea typeface="Aptos"/>
                 <a:cs typeface="Aptos"/>
               </a:rPr>
-              <a:t>Evaluacion del modelo versionado.</a:t>
-            </a:r>
-          </a:p>
-        </p:txBody>
-      </p:sp>
-      <p:sp>
-        <p:nvSpPr>
-          <p:cNvPr id="39" name="">
-            <a:extLst xmlns:a="http://schemas.openxmlformats.org/drawingml/2006/main">
-              <a:ext uri="{FF2B5EF4-FFF2-40B4-BE49-F238E27FC236}">
-                <a16:creationId xmlns:a16="http://schemas.microsoft.com/office/drawing/2014/main" id="{CEB1B434-E65F-445E-AC14-DD55ABADA65B}"/>
-              </a:ext>
-            </a:extLst>
-          </p:cNvPr>
-          <p:cNvSpPr>
-            <a:spLocks xmlns:a="http://schemas.openxmlformats.org/drawingml/2006/main" noGrp="1"/>
-          </p:cNvSpPr>
-          <p:nvPr/>
-        </p:nvSpPr>
-        <p:spPr>
-          <a:xfrm xmlns:a="http://schemas.openxmlformats.org/drawingml/2006/main">
+              <a:t>Demanda hídrica del cultivo tras aplicar Kc.</a:t>
+            </a:r>
+          </a:p>
+        </ns0:txBody>
+      </ns0:sp>
+      <ns0:sp>
+        <ns0:nvSpPr>
+          <ns0:cNvPr id="39" name="">
+            <a:extLst>
+              <a:ext uri="{FF2B5EF4-FFF2-40B4-BE49-F238E27FC236}">
+                <ns2:creationId id="{CEB1B434-E65F-445E-AC14-DD55ABADA65B}"/>
+              </a:ext>
+            </a:extLst>
+          </ns0:cNvPr>
+          <ns0:cNvSpPr>
+            <a:spLocks noGrp="1"/>
+          </ns0:cNvSpPr>
+          <ns0:nvPr/>
+        </ns0:nvSpPr>
+        <ns0:spPr>
+          <a:xfrm>
             <a:off x="685800" y="5753100"/>
             <a:ext cx="10001250" cy="342900"/>
           </a:xfrm>
-          <a:prstGeom xmlns:a="http://schemas.openxmlformats.org/drawingml/2006/main" prst="rect">
-            <a:avLst/>
-          </a:prstGeom>
-          <a:solidFill xmlns:a="http://schemas.openxmlformats.org/drawingml/2006/main">
-            <a:srgbClr val="000000">
-              <a:alpha val="0"/>
-            </a:srgbClr>
-          </a:solidFill>
-          <a:ln xmlns:a="http://schemas.openxmlformats.org/drawingml/2006/main" w="0">
-            <a:solidFill>
-              <a:srgbClr val="000000">
-                <a:alpha val="0"/>
-              </a:srgbClr>
-            </a:solidFill>
-            <a:prstDash val="solid"/>
-          </a:ln>
-        </p:spPr>
-        <p:txBody>
-          <a:bodyPr xmlns:a="http://schemas.openxmlformats.org/drawingml/2006/main" lIns="0" tIns="0" rIns="0" bIns="0" anchor="t"/>
-          <a:lstStyle xmlns:a="http://schemas.openxmlformats.org/drawingml/2006/main"/>
-          <a:p xmlns:a="http://schemas.openxmlformats.org/drawingml/2006/main">
+          <a:prstGeom prst="rect">
+            <a:avLst/>
+          </a:prstGeom>
+          <a:solidFill>
+            <a:srgbClr val="000000">
+              <a:alpha val="0"/>
+            </a:srgbClr>
+          </a:solidFill>
+          <a:ln w="0">
+            <a:solidFill>
+              <a:srgbClr val="000000">
+                <a:alpha val="0"/>
+              </a:srgbClr>
+            </a:solidFill>
+            <a:prstDash val="solid"/>
+          </a:ln>
+        </ns0:spPr>
+        <ns0:txBody>
+          <a:bodyPr lIns="0" tIns="0" rIns="0" bIns="0" anchor="t"/>
+          <a:lstStyle/>
+          <a:p>
             <a:pPr algn="l">
               <a:defRPr sz="1125" b="0">
                 <a:solidFill>
@@ -8853,16 +8853,16 @@
               <a:t>Lectura principal: para el escenario de olivar, el sistema recomienda aproximadamente 97 mil litros en el periodo completo.</a:t>
             </a:r>
           </a:p>
-        </p:txBody>
-      </p:sp>
-    </p:spTree>
-    <p:extLst>
-      <p:ext uri="{BB962C8B-B14F-4D97-AF65-F5344CB8AC3E}">
-        <p14:creationId xmlns:p14="http://schemas.microsoft.com/office/powerpoint/2010/main" val="820374581"/>
-      </p:ext>
-    </p:extLst>
-  </p:cSld>
-</p:sld>
+        </ns0:txBody>
+      </ns0:sp>
+    </ns0:spTree>
+    <ns0:extLst>
+      <ns0:ext uri="{BB962C8B-B14F-4D97-AF65-F5344CB8AC3E}">
+        <ns3:creationId val="820374581"/>
+      </ns0:ext>
+    </ns0:extLst>
+  </ns0:cSld>
+</ns0:sld>
 </file>
 
 <file path=ppt/slides/slide13.xml><?xml version="1.0" encoding="utf-8"?>

</xml_diff>

<commit_message>
Documentar pronostico futuro de riego
</commit_message>
<xml_diff>
--- a/docs/presentacion_defensa_tfg_riego_jurado.pptx
+++ b/docs/presentacion_defensa_tfg_riego_jurado.pptx
@@ -3216,7 +3216,7 @@
                 <a:ea typeface="Aptos Display"/>
                 <a:cs typeface="Aptos Display"/>
               </a:rPr>
-              <a:t>La capa ML aprende a predecir la lámina de riego a partir de clima, cultivo y parcela.</a:t>
+              <a:t>La capa ML estima la lámina de riego; para siete días futuros necesita predicción meteorológica como entrada.</a:t>
             </a:r>
           </a:p>
         </ns0:txBody>
@@ -3280,7 +3280,7 @@
                 <a:ea typeface="Aptos"/>
                 <a:cs typeface="Aptos"/>
               </a:rPr>
-              <a:t>El modelo complementa el cálculo agronómico; no sustituye la necesidad de calibración real en campo.</a:t>
+              <a:t>El modelo complementa el cálculo agronómico; no predice el clima ni sustituye la calibración real en campo.</a:t>
             </a:r>
           </a:p>
         </ns0:txBody>
@@ -3769,7 +3769,7 @@
                 <a:ea typeface="Aptos Display"/>
                 <a:cs typeface="Aptos Display"/>
               </a:rPr>
-              <a:t>Predicción</a:t>
+              <a:t>Predicción operativa</a:t>
             </a:r>
           </a:p>
         </ns0:txBody>
@@ -3833,7 +3833,7 @@
                 <a:ea typeface="Aptos"/>
                 <a:cs typeface="Aptos"/>
               </a:rPr>
-              <a:t>Lámina diaria prevista y conversión a litros de parcela</a:t>
+              <a:t>Lámina diaria y litros con históricos o pronóstico externo</a:t>
             </a:r>
           </a:p>
         </ns0:txBody>
@@ -3965,7 +3965,7 @@
                 <a:ea typeface="Aptos Display"/>
                 <a:cs typeface="Aptos Display"/>
               </a:rPr>
-              <a:t>Calibración</a:t>
+              <a:t>Pronóstico 7 días</a:t>
             </a:r>
           </a:p>
         </ns0:txBody>
@@ -4029,7 +4029,7 @@
                 <a:ea typeface="Aptos"/>
                 <a:cs typeface="Aptos"/>
               </a:rPr>
-              <a:t>Mejora futura con riegos reales aplicados en campo</a:t>
+              <a:t>Funcional cuando exista temperatura y lluvia previstas fiables</a:t>
             </a:r>
           </a:p>
         </ns0:txBody>
@@ -4190,7 +4190,7 @@
                 <a:ea typeface="Aptos"/>
                 <a:cs typeface="Aptos"/>
               </a:rPr>
-              <a:t>En la versión actual, el modelo aprende la referencia técnica del sistema. Con datos reales de explotaciones podría ajustarse para capturar diferencias de manejo, suelo y respuesta local.</a:t>
+              <a:t>En la versión actual, el modelo aprende la referencia técnica del sistema. Para recomendar la semana siguiente debe recibir previsión meteorológica diaria; si solo hay probabilidad de lluvia, la salida debe mostrar incertidumbre.</a:t>
             </a:r>
           </a:p>
         </ns0:txBody>
@@ -5023,7 +5023,7 @@
                 <a:ea typeface="Aptos"/>
                 <a:cs typeface="Aptos"/>
               </a:rPr>
-              <a:t>CSV local versionado</a:t>
+              <a:t>CSV semestral versionado</a:t>
             </a:r>
           </a:p>
         </p:txBody>
@@ -5120,7 +5120,7 @@
                 <a:ea typeface="Aptos"/>
                 <a:cs typeface="Aptos"/>
               </a:rPr>
-              <a:t>Evita saturación de AEMET y garantiza repetibilidad.</a:t>
+              <a:t>Incluye semanas secas y lluviosas sin nuevas peticiones.</a:t>
             </a:r>
           </a:p>
         </p:txBody>
@@ -6639,7 +6639,7 @@
                 <a:ea typeface="Aptos"/>
                 <a:cs typeface="Aptos"/>
               </a:rPr>
-              <a:t>La configuración permite repetir la misma salida de forma reproducible. La app muestra 920 estaciones AEMET, aunque el cálculo CSV se fija a Sevilla Aeropuerto por ser el dataset versionado.</a:t>
+              <a:t>La configuración permite repetir la salida de forma reproducible. La app muestra 920 estaciones AEMET; en CSV local el cálculo se fija a Sevilla Aeropuerto por ser el dataset versionado.</a:t>
             </a:r>
           </a:p>
         </p:txBody>
@@ -8498,7 +8498,7 @@
                 <a:ea typeface="Aptos Display"/>
                 <a:cs typeface="Aptos Display"/>
               </a:rPr>
-              <a:t>97.160 L</a:t>
+              <a:t>94.523 L</a:t>
             </a:r>
           </a:p>
         </p:txBody>
@@ -8562,7 +8562,7 @@
                 <a:ea typeface="Aptos"/>
                 <a:cs typeface="Aptos"/>
               </a:rPr>
-              <a:t>Resultado muy cercano al cálculo base.</a:t>
+              <a:t>Predicción cercana al cálculo base tras entrenar con el CSV semestral.</a:t>
             </a:r>
           </a:p>
         </p:txBody>
@@ -9521,7 +9521,7 @@
                 <a:ea typeface="Aptos"/>
                 <a:cs typeface="Aptos"/>
               </a:rPr>
-              <a:t>El CSV de Sevilla está versionado para repetir la salida sin depender de la API.</a:t>
+              <a:t>El CSV semestral de Sevilla está versionado para repetir escenarios secos y lluviosos sin depender de la API.</a:t>
             </a:r>
           </a:p>
         </p:txBody>
@@ -11157,7 +11157,7 @@
                 <a:ea typeface="Aptos"/>
                 <a:cs typeface="Aptos"/>
               </a:rPr>
-              <a:t>AEMET puede limitar peticiones; por eso se usa caché local en la validación.</a:t>
+              <a:t>AEMET puede limitar peticiones y el pronóstico futuro exige temperatura y lluvia diaria fiables.</a:t>
             </a:r>
           </a:p>
         </p:txBody>
@@ -11479,7 +11479,7 @@
                 <a:ea typeface="Aptos"/>
                 <a:cs typeface="Aptos"/>
               </a:rPr>
-              <a:t>La precisión real aumentaría con datos históricos de parcela y respuesta del cultivo.</a:t>
+              <a:t>La precisión real aumentaría con riegos medidos, respuesta del cultivo y validación por parcela.</a:t>
             </a:r>
           </a:p>
         </p:txBody>
@@ -11699,7 +11699,7 @@
                 <a:ea typeface="Aptos"/>
                 <a:cs typeface="Aptos"/>
               </a:rPr>
-              <a:t>EVOLUCIÓN FUTURA</a:t>
+              <a:t>PRONÓSTICO 7 DÍAS</a:t>
             </a:r>
           </a:p>
         </ns0:txBody>
@@ -11763,7 +11763,7 @@
                 <a:ea typeface="Aptos Display"/>
                 <a:cs typeface="Aptos Display"/>
               </a:rPr>
-              <a:t>El camino de mejora convierte el prototipo en un servicio predictivo de mayor valor.</a:t>
+              <a:t>La evolución inmediata es anticipar el riego semanal con predicción meteorológica externa.</a:t>
             </a:r>
           </a:p>
         </ns0:txBody>
@@ -11827,7 +11827,7 @@
                 <a:ea typeface="Aptos"/>
                 <a:cs typeface="Aptos"/>
               </a:rPr>
-              <a:t>La arquitectura actual permite crecer sin perder trazabilidad.</a:t>
+              <a:t>El flujo está preparado, pero depende de datos futuros fiables y calibración de campo.</a:t>
             </a:r>
           </a:p>
         </ns0:txBody>
@@ -11988,7 +11988,7 @@
                 <a:ea typeface="Aptos"/>
                 <a:cs typeface="Aptos"/>
               </a:rPr>
-              <a:t>Riegos reales</a:t>
+              <a:t>Predicción AEMET</a:t>
             </a:r>
           </a:p>
         </ns0:txBody>
@@ -12052,7 +12052,7 @@
                 <a:ea typeface="Aptos"/>
                 <a:cs typeface="Aptos"/>
               </a:rPr>
-              <a:t>Etiquetas de campo para calibrar el modelo</a:t>
+              <a:t>Temperatura y lluvia diaria previstas</a:t>
             </a:r>
           </a:p>
         </ns0:txBody>
@@ -12248,7 +12248,7 @@
                 <a:ea typeface="Aptos"/>
                 <a:cs typeface="Aptos"/>
               </a:rPr>
-              <a:t>Sensores IoT</a:t>
+              <a:t>Horizonte 7 días</a:t>
             </a:r>
           </a:p>
         </ns0:txBody>
@@ -12312,7 +12312,7 @@
                 <a:ea typeface="Aptos"/>
                 <a:cs typeface="Aptos"/>
               </a:rPr>
-              <a:t>Humedad de suelo y respuesta local</a:t>
+              <a:t>Recomendación anticipada por parcela</a:t>
             </a:r>
           </a:p>
         </ns0:txBody>
@@ -12508,7 +12508,7 @@
                 <a:ea typeface="Aptos"/>
                 <a:cs typeface="Aptos"/>
               </a:rPr>
-              <a:t>Predicción climática</a:t>
+              <a:t>Entrada ML</a:t>
             </a:r>
           </a:p>
         </ns0:txBody>
@@ -12572,7 +12572,7 @@
                 <a:ea typeface="Aptos"/>
                 <a:cs typeface="Aptos"/>
               </a:rPr>
-              <a:t>Incorporar previsión meteorológica</a:t>
+              <a:t>El modelo usa el pronóstico; no genera el clima</a:t>
             </a:r>
           </a:p>
         </ns0:txBody>
@@ -12768,7 +12768,7 @@
                 <a:ea typeface="Aptos"/>
                 <a:cs typeface="Aptos"/>
               </a:rPr>
-              <a:t>BigQuery</a:t>
+              <a:t>Incertidumbre</a:t>
             </a:r>
           </a:p>
         </ns0:txBody>
@@ -12832,7 +12832,7 @@
                 <a:ea typeface="Aptos"/>
                 <a:cs typeface="Aptos"/>
               </a:rPr>
-              <a:t>Históricos y escalado de datos</a:t>
+              <a:t>Aviso si solo hay probabilidad de lluvia</a:t>
             </a:r>
           </a:p>
         </ns0:txBody>
@@ -13028,7 +13028,7 @@
                 <a:ea typeface="Aptos"/>
                 <a:cs typeface="Aptos"/>
               </a:rPr>
-              <a:t>Parcelas</a:t>
+              <a:t>Calibración</a:t>
             </a:r>
           </a:p>
         </ns0:txBody>
@@ -13092,7 +13092,7 @@
                 <a:ea typeface="Aptos"/>
                 <a:cs typeface="Aptos"/>
               </a:rPr>
-              <a:t>Gestión de clientes y ubicaciones</a:t>
+              <a:t>Riegos reales para ajustar parcela</a:t>
             </a:r>
           </a:p>
         </ns0:txBody>
@@ -13352,7 +13352,7 @@
                 <a:ea typeface="Aptos"/>
                 <a:cs typeface="Aptos"/>
               </a:rPr>
-              <a:t>Recomendaciones recurrentes</a:t>
+              <a:t>Envío recurrente al cliente</a:t>
             </a:r>
           </a:p>
         </ns0:txBody>
@@ -13612,7 +13612,7 @@
                 <a:ea typeface="Aptos"/>
                 <a:cs typeface="Aptos"/>
               </a:rPr>
-              <a:t>Servicio comercializable</a:t>
+              <a:t>Módulo comercial ampliable</a:t>
             </a:r>
           </a:p>
         </ns0:txBody>
@@ -13709,7 +13709,7 @@
                 <a:ea typeface="Aptos"/>
                 <a:cs typeface="Aptos"/>
               </a:rPr>
-              <a:t>La prioridad de la siguiente fase sería entrenar con riegos reales para pasar de una referencia técnica a un modelo calibrado por parcela.</a:t>
+              <a:t>La demo estable se mantiene con históricos reales; el pronóstico futuro se activaría cuando la fuente meteorológica y la calibración cumplan esas condiciones.</a:t>
             </a:r>
           </a:p>
         </ns0:txBody>

</xml_diff>

<commit_message>
Incorporar ROI y modelo comercial
</commit_message>
<xml_diff>
--- a/docs/presentacion_defensa_tfg_riego_jurado.pptx
+++ b/docs/presentacion_defensa_tfg_riego_jurado.pptx
@@ -13929,7 +13929,7 @@
                 <a:ea typeface="Aptos"/>
                 <a:cs typeface="Aptos"/>
               </a:rPr>
-              <a:t>CONCLUSIÓN</a:t>
+              <a:t>MODELO DE SERVICIO Y ROI</a:t>
             </a:r>
           </a:p>
         </p:txBody>
@@ -13993,7 +13993,7 @@
                 <a:ea typeface="Aptos Display"/>
                 <a:cs typeface="Aptos Display"/>
               </a:rPr>
-              <a:t>El proyecto demuestra una cadena completa desde el dato oficial hasta la recomendación de riego.</a:t>
+              <a:t>La venta se plantea como informe semanal o mensual de recomendación, no como automatización hidráulica.</a:t>
             </a:r>
           </a:p>
         </p:txBody>
@@ -14057,7 +14057,7 @@
                 <a:ea typeface="Aptos"/>
                 <a:cs typeface="Aptos"/>
               </a:rPr>
-              <a:t>El resultado es un prototipo técnicamente justificable, reproducible y ampliable.</a:t>
+              <a:t>El ROI se presenta como simulación con supuestos explícitos, no como ahorro real medido en campo.</a:t>
             </a:r>
           </a:p>
         </p:txBody>
@@ -14154,7 +14154,7 @@
                 <a:ea typeface="Aptos Display"/>
                 <a:cs typeface="Aptos Display"/>
               </a:rPr>
-              <a:t>El sistema responde a una pregunta concreta: cuánta agua necesita una plantación según lugar, cultivo, fechas y superficie.</a:t>
+              <a:t>Precio estimado: 15 EUR por informe semanal o 49 EUR al mes. Coste interno: 30 min de revisión técnica + 1,50 EUR de gestión, unos 9 EUR por informe.</a:t>
             </a:r>
           </a:p>
         </p:txBody>
@@ -14253,7 +14253,7 @@
                 <a:ea typeface="Aptos"/>
                 <a:cs typeface="Aptos"/>
               </a:rPr>
-              <a:t>La solución no depende del número de goteros; se centra en la demanda hídrica de la parcela y en una salida comprensible para el agricultor.</a:t>
+              <a:t>Escenario demo: ahorro = agua/energía evitada + 1 h de revisión. Con +15 % de riego tradicional, ROI semanal estimado del cliente: 38,9 %; ROI mensual: 70,0 %.</a:t>
             </a:r>
           </a:p>
         </p:txBody>

</xml_diff>

<commit_message>
Limpiar metadatos y redaccion documental
</commit_message>
<xml_diff>
--- a/docs/presentacion_defensa_tfg_riego_jurado.pptx
+++ b/docs/presentacion_defensa_tfg_riego_jurado.pptx
@@ -30065,9 +30065,9 @@
 </file>
 
 <file path=ppt/theme/theme1.xml><?xml version="1.0" encoding="utf-8"?>
-<a:theme xmlns:a="http://schemas.openxmlformats.org/drawingml/2006/main" name="ChatGPT">
+<a:theme xmlns:a="http://schemas.openxmlformats.org/drawingml/2006/main" name="Aptos">
   <a:themeElements>
-    <a:clrScheme name="ChatGPT">
+    <a:clrScheme name="Aptos">
       <a:dk1>
         <a:srgbClr val="000000"/>
       </a:dk1>
@@ -30117,7 +30117,7 @@
         <a:cs typeface="Calibri"/>
       </a:minorFont>
     </a:fontScheme>
-    <a:fmtScheme name="ChatGPT">
+    <a:fmtScheme name="Aptos">
       <a:fillStyleLst>
         <a:solidFill>
           <a:schemeClr val="phClr"/>
@@ -30266,9 +30266,9 @@
 </file>
 
 <file path=ppt/theme/theme2.xml><?xml version="1.0" encoding="utf-8"?>
-<a:theme xmlns:a="http://schemas.openxmlformats.org/drawingml/2006/main" name="ChatGPT">
+<a:theme xmlns:a="http://schemas.openxmlformats.org/drawingml/2006/main" name="Aptos">
   <a:themeElements>
-    <a:clrScheme name="ChatGPT">
+    <a:clrScheme name="Aptos">
       <a:dk1>
         <a:srgbClr val="000000"/>
       </a:dk1>
@@ -30318,7 +30318,7 @@
         <a:cs typeface="Calibri"/>
       </a:minorFont>
     </a:fontScheme>
-    <a:fmtScheme name="ChatGPT">
+    <a:fmtScheme name="Aptos">
       <a:fillStyleLst>
         <a:solidFill>
           <a:schemeClr val="phClr"/>

</xml_diff>